<commit_message>
Center columns and sort by deadline
</commit_message>
<xml_diff>
--- a/NovaClose_App_Presentation.pptx
+++ b/NovaClose_App_Presentation.pptx
@@ -13,6 +13,7 @@
     <p:sldId id="261" r:id="rId12"/>
     <p:sldId id="262" r:id="rId13"/>
     <p:sldId id="263" r:id="rId14"/>
+    <p:sldId id="264" r:id="rId15"/>
   </p:sldIdLst>
   <p:sldSz cx="12191695" cy="6858000" type="screen4x3"/>
   <p:notesSz cx="6858000" cy="9144000"/>
@@ -7073,7 +7074,7 @@
                   <a:srgbClr val="0F1F2C"/>
                 </a:solidFill>
               </a:rPr>
-              <a:t>Agent suite</a:t>
+              <a:t>Tools used to build the app</a:t>
             </a:r>
           </a:p>
         </p:txBody>
@@ -7106,175 +7107,998 @@
                   <a:srgbClr val="5B6B78"/>
                 </a:solidFill>
               </a:rPr>
-              <a:t>Each agent owns a specific part of the close and feeds a common readiness and posting model.</a:t>
-            </a:r>
-          </a:p>
-        </p:txBody>
-      </p:sp>
-      <p:sp>
-        <p:nvSpPr>
-          <p:cNvPr id="4" name="TextBox 3"/>
-          <p:cNvSpPr txBox="1"/>
-          <p:nvPr/>
-        </p:nvSpPr>
-        <p:spPr>
-          <a:xfrm>
-            <a:off x="731520" y="1371600"/>
-            <a:ext cx="10972800" cy="274320"/>
-          </a:xfrm>
-          <a:prstGeom prst="rect">
-            <a:avLst/>
-          </a:prstGeom>
-          <a:noFill/>
-        </p:spPr>
-        <p:txBody>
-          <a:bodyPr wrap="none">
-            <a:spAutoFit/>
-          </a:bodyPr>
-          <a:lstStyle/>
-          <a:p>
-            <a:r>
-              <a:rPr sz="1000" b="1">
+              <a:t>The prototype was built with a lightweight analytics and demo stack that is easy to explain and scale.</a:t>
+            </a:r>
+          </a:p>
+        </p:txBody>
+      </p:sp>
+      <p:sp>
+        <p:nvSpPr>
+          <p:cNvPr id="4" name="Rounded Rectangle 3"/>
+          <p:cNvSpPr/>
+          <p:nvPr/>
+        </p:nvSpPr>
+        <p:spPr>
+          <a:xfrm>
+            <a:off x="731520" y="1417320"/>
+            <a:ext cx="5212080" cy="1051560"/>
+          </a:xfrm>
+          <a:prstGeom prst="roundRect">
+            <a:avLst/>
+          </a:prstGeom>
+          <a:solidFill>
+            <a:srgbClr val="FFFFFF"/>
+          </a:solidFill>
+          <a:ln w="12700">
+            <a:solidFill>
+              <a:srgbClr val="D6DFE5"/>
+            </a:solidFill>
+          </a:ln>
+        </p:spPr>
+        <p:style>
+          <a:lnRef idx="1">
+            <a:schemeClr val="accent1"/>
+          </a:lnRef>
+          <a:fillRef idx="3">
+            <a:schemeClr val="accent1"/>
+          </a:fillRef>
+          <a:effectRef idx="2">
+            <a:schemeClr val="accent1"/>
+          </a:effectRef>
+          <a:fontRef idx="minor">
+            <a:schemeClr val="lt1"/>
+          </a:fontRef>
+        </p:style>
+        <p:txBody>
+          <a:bodyPr rtlCol="0" anchor="ctr"/>
+          <a:lstStyle/>
+          <a:p>
+            <a:pPr algn="ctr"/>
+          </a:p>
+        </p:txBody>
+      </p:sp>
+      <p:sp>
+        <p:nvSpPr>
+          <p:cNvPr id="5" name="Rounded Rectangle 4"/>
+          <p:cNvSpPr/>
+          <p:nvPr/>
+        </p:nvSpPr>
+        <p:spPr>
+          <a:xfrm>
+            <a:off x="896112" y="1581912"/>
+            <a:ext cx="658368" cy="658368"/>
+          </a:xfrm>
+          <a:prstGeom prst="roundRect">
+            <a:avLst/>
+          </a:prstGeom>
+          <a:solidFill>
+            <a:srgbClr val="3572A5"/>
+          </a:solidFill>
+          <a:ln>
+            <a:solidFill>
+              <a:srgbClr val="3572A5"/>
+            </a:solidFill>
+          </a:ln>
+        </p:spPr>
+        <p:style>
+          <a:lnRef idx="1">
+            <a:schemeClr val="accent1"/>
+          </a:lnRef>
+          <a:fillRef idx="3">
+            <a:schemeClr val="accent1"/>
+          </a:fillRef>
+          <a:effectRef idx="2">
+            <a:schemeClr val="accent1"/>
+          </a:effectRef>
+          <a:fontRef idx="minor">
+            <a:schemeClr val="lt1"/>
+          </a:fontRef>
+        </p:style>
+        <p:txBody>
+          <a:bodyPr rtlCol="0" anchor="ctr"/>
+          <a:lstStyle/>
+          <a:p>
+            <a:pPr algn="ctr"/>
+            <a:r>
+              <a:rPr sz="1800" b="1">
+                <a:solidFill>
+                  <a:srgbClr val="FFFFFF"/>
+                </a:solidFill>
+              </a:rPr>
+              <a:t>Py</a:t>
+            </a:r>
+          </a:p>
+        </p:txBody>
+      </p:sp>
+      <p:sp>
+        <p:nvSpPr>
+          <p:cNvPr id="6" name="TextBox 5"/>
+          <p:cNvSpPr txBox="1"/>
+          <p:nvPr/>
+        </p:nvSpPr>
+        <p:spPr>
+          <a:xfrm>
+            <a:off x="1691640" y="1600200"/>
+            <a:ext cx="4069080" cy="274320"/>
+          </a:xfrm>
+          <a:prstGeom prst="rect">
+            <a:avLst/>
+          </a:prstGeom>
+          <a:noFill/>
+        </p:spPr>
+        <p:txBody>
+          <a:bodyPr wrap="none">
+            <a:spAutoFit/>
+          </a:bodyPr>
+          <a:lstStyle/>
+          <a:p>
+            <a:r>
+              <a:rPr sz="1600" b="1">
+                <a:solidFill>
+                  <a:srgbClr val="0F1F2C"/>
+                </a:solidFill>
+              </a:rPr>
+              <a:t>Python</a:t>
+            </a:r>
+          </a:p>
+        </p:txBody>
+      </p:sp>
+      <p:sp>
+        <p:nvSpPr>
+          <p:cNvPr id="7" name="TextBox 6"/>
+          <p:cNvSpPr txBox="1"/>
+          <p:nvPr/>
+        </p:nvSpPr>
+        <p:spPr>
+          <a:xfrm>
+            <a:off x="1691640" y="1920240"/>
+            <a:ext cx="4069080" cy="566928"/>
+          </a:xfrm>
+          <a:prstGeom prst="rect">
+            <a:avLst/>
+          </a:prstGeom>
+          <a:noFill/>
+        </p:spPr>
+        <p:txBody>
+          <a:bodyPr wrap="none">
+            <a:spAutoFit/>
+          </a:bodyPr>
+          <a:lstStyle/>
+          <a:p>
+            <a:r>
+              <a:rPr sz="1100">
                 <a:solidFill>
                   <a:srgbClr val="5B6B78"/>
                 </a:solidFill>
               </a:rPr>
-              <a:t>WHAT MOVED OUT OF THE UI AND INTO THE DECK</a:t>
-            </a:r>
-          </a:p>
-        </p:txBody>
-      </p:sp>
-      <p:sp>
-        <p:nvSpPr>
-          <p:cNvPr id="5" name="TextBox 4"/>
-          <p:cNvSpPr txBox="1"/>
-          <p:nvPr/>
-        </p:nvSpPr>
-        <p:spPr>
-          <a:xfrm>
-            <a:off x="731520" y="1645920"/>
-            <a:ext cx="10972800" cy="4754880"/>
-          </a:xfrm>
-          <a:prstGeom prst="rect">
-            <a:avLst/>
-          </a:prstGeom>
-          <a:noFill/>
-        </p:spPr>
-        <p:txBody>
-          <a:bodyPr wrap="none">
-            <a:spAutoFit/>
-          </a:bodyPr>
-          <a:lstStyle/>
-          <a:p>
-            <a:pPr>
-              <a:spcAft>
-                <a:spcPts val="800"/>
-              </a:spcAft>
-              <a:defRPr sz="1500">
+              <a:t>Core analysis engine, agent logic, scenario model, and orchestration.</a:t>
+            </a:r>
+          </a:p>
+        </p:txBody>
+      </p:sp>
+      <p:sp>
+        <p:nvSpPr>
+          <p:cNvPr id="8" name="Rounded Rectangle 7"/>
+          <p:cNvSpPr/>
+          <p:nvPr/>
+        </p:nvSpPr>
+        <p:spPr>
+          <a:xfrm>
+            <a:off x="6080760" y="1417320"/>
+            <a:ext cx="5212080" cy="1051560"/>
+          </a:xfrm>
+          <a:prstGeom prst="roundRect">
+            <a:avLst/>
+          </a:prstGeom>
+          <a:solidFill>
+            <a:srgbClr val="FFFFFF"/>
+          </a:solidFill>
+          <a:ln w="12700">
+            <a:solidFill>
+              <a:srgbClr val="D6DFE5"/>
+            </a:solidFill>
+          </a:ln>
+        </p:spPr>
+        <p:style>
+          <a:lnRef idx="1">
+            <a:schemeClr val="accent1"/>
+          </a:lnRef>
+          <a:fillRef idx="3">
+            <a:schemeClr val="accent1"/>
+          </a:fillRef>
+          <a:effectRef idx="2">
+            <a:schemeClr val="accent1"/>
+          </a:effectRef>
+          <a:fontRef idx="minor">
+            <a:schemeClr val="lt1"/>
+          </a:fontRef>
+        </p:style>
+        <p:txBody>
+          <a:bodyPr rtlCol="0" anchor="ctr"/>
+          <a:lstStyle/>
+          <a:p>
+            <a:pPr algn="ctr"/>
+          </a:p>
+        </p:txBody>
+      </p:sp>
+      <p:sp>
+        <p:nvSpPr>
+          <p:cNvPr id="9" name="Rounded Rectangle 8"/>
+          <p:cNvSpPr/>
+          <p:nvPr/>
+        </p:nvSpPr>
+        <p:spPr>
+          <a:xfrm>
+            <a:off x="6245352" y="1581912"/>
+            <a:ext cx="658368" cy="658368"/>
+          </a:xfrm>
+          <a:prstGeom prst="roundRect">
+            <a:avLst/>
+          </a:prstGeom>
+          <a:solidFill>
+            <a:srgbClr val="FF4B4B"/>
+          </a:solidFill>
+          <a:ln>
+            <a:solidFill>
+              <a:srgbClr val="FF4B4B"/>
+            </a:solidFill>
+          </a:ln>
+        </p:spPr>
+        <p:style>
+          <a:lnRef idx="1">
+            <a:schemeClr val="accent1"/>
+          </a:lnRef>
+          <a:fillRef idx="3">
+            <a:schemeClr val="accent1"/>
+          </a:fillRef>
+          <a:effectRef idx="2">
+            <a:schemeClr val="accent1"/>
+          </a:effectRef>
+          <a:fontRef idx="minor">
+            <a:schemeClr val="lt1"/>
+          </a:fontRef>
+        </p:style>
+        <p:txBody>
+          <a:bodyPr rtlCol="0" anchor="ctr"/>
+          <a:lstStyle/>
+          <a:p>
+            <a:pPr algn="ctr"/>
+            <a:r>
+              <a:rPr sz="1800" b="1">
+                <a:solidFill>
+                  <a:srgbClr val="FFFFFF"/>
+                </a:solidFill>
+              </a:rPr>
+              <a:t>st</a:t>
+            </a:r>
+          </a:p>
+        </p:txBody>
+      </p:sp>
+      <p:sp>
+        <p:nvSpPr>
+          <p:cNvPr id="10" name="TextBox 9"/>
+          <p:cNvSpPr txBox="1"/>
+          <p:nvPr/>
+        </p:nvSpPr>
+        <p:spPr>
+          <a:xfrm>
+            <a:off x="7040880" y="1600200"/>
+            <a:ext cx="4069080" cy="274320"/>
+          </a:xfrm>
+          <a:prstGeom prst="rect">
+            <a:avLst/>
+          </a:prstGeom>
+          <a:noFill/>
+        </p:spPr>
+        <p:txBody>
+          <a:bodyPr wrap="none">
+            <a:spAutoFit/>
+          </a:bodyPr>
+          <a:lstStyle/>
+          <a:p>
+            <a:r>
+              <a:rPr sz="1600" b="1">
                 <a:solidFill>
                   <a:srgbClr val="0F1F2C"/>
                 </a:solidFill>
-              </a:defRPr>
-            </a:pPr>
-            <a:r>
-              <a:t>GL Approval Agent: Triages pending journals into straight-through, manager, controller, and CFO lanes.</a:t>
-            </a:r>
-          </a:p>
-          <a:p>
-            <a:pPr>
-              <a:spcAft>
-                <a:spcPts val="800"/>
-              </a:spcAft>
-              <a:defRPr sz="1500">
+              </a:rPr>
+              <a:t>Streamlit</a:t>
+            </a:r>
+          </a:p>
+        </p:txBody>
+      </p:sp>
+      <p:sp>
+        <p:nvSpPr>
+          <p:cNvPr id="11" name="TextBox 10"/>
+          <p:cNvSpPr txBox="1"/>
+          <p:nvPr/>
+        </p:nvSpPr>
+        <p:spPr>
+          <a:xfrm>
+            <a:off x="7040880" y="1920240"/>
+            <a:ext cx="4069080" cy="566928"/>
+          </a:xfrm>
+          <a:prstGeom prst="rect">
+            <a:avLst/>
+          </a:prstGeom>
+          <a:noFill/>
+        </p:spPr>
+        <p:txBody>
+          <a:bodyPr wrap="none">
+            <a:spAutoFit/>
+          </a:bodyPr>
+          <a:lstStyle/>
+          <a:p>
+            <a:r>
+              <a:rPr sz="1100">
+                <a:solidFill>
+                  <a:srgbClr val="5B6B78"/>
+                </a:solidFill>
+              </a:rPr>
+              <a:t>Interactive demo application, command centre UI, and guided month-end workflow.</a:t>
+            </a:r>
+          </a:p>
+        </p:txBody>
+      </p:sp>
+      <p:sp>
+        <p:nvSpPr>
+          <p:cNvPr id="12" name="Rounded Rectangle 11"/>
+          <p:cNvSpPr/>
+          <p:nvPr/>
+        </p:nvSpPr>
+        <p:spPr>
+          <a:xfrm>
+            <a:off x="731520" y="2743200"/>
+            <a:ext cx="5212080" cy="1051560"/>
+          </a:xfrm>
+          <a:prstGeom prst="roundRect">
+            <a:avLst/>
+          </a:prstGeom>
+          <a:solidFill>
+            <a:srgbClr val="FFFFFF"/>
+          </a:solidFill>
+          <a:ln w="12700">
+            <a:solidFill>
+              <a:srgbClr val="D6DFE5"/>
+            </a:solidFill>
+          </a:ln>
+        </p:spPr>
+        <p:style>
+          <a:lnRef idx="1">
+            <a:schemeClr val="accent1"/>
+          </a:lnRef>
+          <a:fillRef idx="3">
+            <a:schemeClr val="accent1"/>
+          </a:fillRef>
+          <a:effectRef idx="2">
+            <a:schemeClr val="accent1"/>
+          </a:effectRef>
+          <a:fontRef idx="minor">
+            <a:schemeClr val="lt1"/>
+          </a:fontRef>
+        </p:style>
+        <p:txBody>
+          <a:bodyPr rtlCol="0" anchor="ctr"/>
+          <a:lstStyle/>
+          <a:p>
+            <a:pPr algn="ctr"/>
+          </a:p>
+        </p:txBody>
+      </p:sp>
+      <p:sp>
+        <p:nvSpPr>
+          <p:cNvPr id="13" name="Rounded Rectangle 12"/>
+          <p:cNvSpPr/>
+          <p:nvPr/>
+        </p:nvSpPr>
+        <p:spPr>
+          <a:xfrm>
+            <a:off x="896112" y="2907792"/>
+            <a:ext cx="658368" cy="658368"/>
+          </a:xfrm>
+          <a:prstGeom prst="roundRect">
+            <a:avLst/>
+          </a:prstGeom>
+          <a:solidFill>
+            <a:srgbClr val="156355"/>
+          </a:solidFill>
+          <a:ln>
+            <a:solidFill>
+              <a:srgbClr val="156355"/>
+            </a:solidFill>
+          </a:ln>
+        </p:spPr>
+        <p:style>
+          <a:lnRef idx="1">
+            <a:schemeClr val="accent1"/>
+          </a:lnRef>
+          <a:fillRef idx="3">
+            <a:schemeClr val="accent1"/>
+          </a:fillRef>
+          <a:effectRef idx="2">
+            <a:schemeClr val="accent1"/>
+          </a:effectRef>
+          <a:fontRef idx="minor">
+            <a:schemeClr val="lt1"/>
+          </a:fontRef>
+        </p:style>
+        <p:txBody>
+          <a:bodyPr rtlCol="0" anchor="ctr"/>
+          <a:lstStyle/>
+          <a:p>
+            <a:pPr algn="ctr"/>
+            <a:r>
+              <a:rPr sz="1800" b="1">
+                <a:solidFill>
+                  <a:srgbClr val="FFFFFF"/>
+                </a:solidFill>
+              </a:rPr>
+              <a:t>pd</a:t>
+            </a:r>
+          </a:p>
+        </p:txBody>
+      </p:sp>
+      <p:sp>
+        <p:nvSpPr>
+          <p:cNvPr id="14" name="TextBox 13"/>
+          <p:cNvSpPr txBox="1"/>
+          <p:nvPr/>
+        </p:nvSpPr>
+        <p:spPr>
+          <a:xfrm>
+            <a:off x="1691640" y="2926080"/>
+            <a:ext cx="4069080" cy="274320"/>
+          </a:xfrm>
+          <a:prstGeom prst="rect">
+            <a:avLst/>
+          </a:prstGeom>
+          <a:noFill/>
+        </p:spPr>
+        <p:txBody>
+          <a:bodyPr wrap="none">
+            <a:spAutoFit/>
+          </a:bodyPr>
+          <a:lstStyle/>
+          <a:p>
+            <a:r>
+              <a:rPr sz="1600" b="1">
                 <a:solidFill>
                   <a:srgbClr val="0F1F2C"/>
                 </a:solidFill>
-              </a:defRPr>
-            </a:pPr>
-            <a:r>
-              <a:t>Bank Reconciliation Agent: Routes cash exceptions, drafts residual journals, and isolates statement breaks.</a:t>
-            </a:r>
-          </a:p>
-          <a:p>
-            <a:pPr>
-              <a:spcAft>
-                <a:spcPts val="800"/>
-              </a:spcAft>
-              <a:defRPr sz="1500">
+              </a:rPr>
+              <a:t>Pandas</a:t>
+            </a:r>
+          </a:p>
+        </p:txBody>
+      </p:sp>
+      <p:sp>
+        <p:nvSpPr>
+          <p:cNvPr id="15" name="TextBox 14"/>
+          <p:cNvSpPr txBox="1"/>
+          <p:nvPr/>
+        </p:nvSpPr>
+        <p:spPr>
+          <a:xfrm>
+            <a:off x="1691640" y="3246120"/>
+            <a:ext cx="4069080" cy="566928"/>
+          </a:xfrm>
+          <a:prstGeom prst="rect">
+            <a:avLst/>
+          </a:prstGeom>
+          <a:noFill/>
+        </p:spPr>
+        <p:txBody>
+          <a:bodyPr wrap="none">
+            <a:spAutoFit/>
+          </a:bodyPr>
+          <a:lstStyle/>
+          <a:p>
+            <a:r>
+              <a:rPr sz="1100">
+                <a:solidFill>
+                  <a:srgbClr val="5B6B78"/>
+                </a:solidFill>
+              </a:rPr>
+              <a:t>Workbook shaping, KPI calculations, exception analysis, and agent worklists.</a:t>
+            </a:r>
+          </a:p>
+        </p:txBody>
+      </p:sp>
+      <p:sp>
+        <p:nvSpPr>
+          <p:cNvPr id="16" name="Rounded Rectangle 15"/>
+          <p:cNvSpPr/>
+          <p:nvPr/>
+        </p:nvSpPr>
+        <p:spPr>
+          <a:xfrm>
+            <a:off x="6080760" y="2743200"/>
+            <a:ext cx="5212080" cy="1051560"/>
+          </a:xfrm>
+          <a:prstGeom prst="roundRect">
+            <a:avLst/>
+          </a:prstGeom>
+          <a:solidFill>
+            <a:srgbClr val="FFFFFF"/>
+          </a:solidFill>
+          <a:ln w="12700">
+            <a:solidFill>
+              <a:srgbClr val="D6DFE5"/>
+            </a:solidFill>
+          </a:ln>
+        </p:spPr>
+        <p:style>
+          <a:lnRef idx="1">
+            <a:schemeClr val="accent1"/>
+          </a:lnRef>
+          <a:fillRef idx="3">
+            <a:schemeClr val="accent1"/>
+          </a:fillRef>
+          <a:effectRef idx="2">
+            <a:schemeClr val="accent1"/>
+          </a:effectRef>
+          <a:fontRef idx="minor">
+            <a:schemeClr val="lt1"/>
+          </a:fontRef>
+        </p:style>
+        <p:txBody>
+          <a:bodyPr rtlCol="0" anchor="ctr"/>
+          <a:lstStyle/>
+          <a:p>
+            <a:pPr algn="ctr"/>
+          </a:p>
+        </p:txBody>
+      </p:sp>
+      <p:sp>
+        <p:nvSpPr>
+          <p:cNvPr id="17" name="Rounded Rectangle 16"/>
+          <p:cNvSpPr/>
+          <p:nvPr/>
+        </p:nvSpPr>
+        <p:spPr>
+          <a:xfrm>
+            <a:off x="6245352" y="2907792"/>
+            <a:ext cx="658368" cy="658368"/>
+          </a:xfrm>
+          <a:prstGeom prst="roundRect">
+            <a:avLst/>
+          </a:prstGeom>
+          <a:solidFill>
+            <a:srgbClr val="636EFA"/>
+          </a:solidFill>
+          <a:ln>
+            <a:solidFill>
+              <a:srgbClr val="636EFA"/>
+            </a:solidFill>
+          </a:ln>
+        </p:spPr>
+        <p:style>
+          <a:lnRef idx="1">
+            <a:schemeClr val="accent1"/>
+          </a:lnRef>
+          <a:fillRef idx="3">
+            <a:schemeClr val="accent1"/>
+          </a:fillRef>
+          <a:effectRef idx="2">
+            <a:schemeClr val="accent1"/>
+          </a:effectRef>
+          <a:fontRef idx="minor">
+            <a:schemeClr val="lt1"/>
+          </a:fontRef>
+        </p:style>
+        <p:txBody>
+          <a:bodyPr rtlCol="0" anchor="ctr"/>
+          <a:lstStyle/>
+          <a:p>
+            <a:pPr algn="ctr"/>
+            <a:r>
+              <a:rPr sz="1800" b="1">
+                <a:solidFill>
+                  <a:srgbClr val="FFFFFF"/>
+                </a:solidFill>
+              </a:rPr>
+              <a:t>pl</a:t>
+            </a:r>
+          </a:p>
+        </p:txBody>
+      </p:sp>
+      <p:sp>
+        <p:nvSpPr>
+          <p:cNvPr id="18" name="TextBox 17"/>
+          <p:cNvSpPr txBox="1"/>
+          <p:nvPr/>
+        </p:nvSpPr>
+        <p:spPr>
+          <a:xfrm>
+            <a:off x="7040880" y="2926080"/>
+            <a:ext cx="4069080" cy="274320"/>
+          </a:xfrm>
+          <a:prstGeom prst="rect">
+            <a:avLst/>
+          </a:prstGeom>
+          <a:noFill/>
+        </p:spPr>
+        <p:txBody>
+          <a:bodyPr wrap="none">
+            <a:spAutoFit/>
+          </a:bodyPr>
+          <a:lstStyle/>
+          <a:p>
+            <a:r>
+              <a:rPr sz="1600" b="1">
                 <a:solidFill>
                   <a:srgbClr val="0F1F2C"/>
                 </a:solidFill>
-              </a:defRPr>
-            </a:pPr>
-            <a:r>
-              <a:t>IC Reconciliation Agent: Auto-matches counterparties, resolves FX mismatches, and drafts eliminations.</a:t>
-            </a:r>
-          </a:p>
-          <a:p>
-            <a:pPr>
-              <a:spcAft>
-                <a:spcPts val="800"/>
-              </a:spcAft>
-              <a:defRPr sz="1500">
+              </a:rPr>
+              <a:t>Plotly</a:t>
+            </a:r>
+          </a:p>
+        </p:txBody>
+      </p:sp>
+      <p:sp>
+        <p:nvSpPr>
+          <p:cNvPr id="19" name="TextBox 18"/>
+          <p:cNvSpPr txBox="1"/>
+          <p:nvPr/>
+        </p:nvSpPr>
+        <p:spPr>
+          <a:xfrm>
+            <a:off x="7040880" y="3246120"/>
+            <a:ext cx="4069080" cy="566928"/>
+          </a:xfrm>
+          <a:prstGeom prst="rect">
+            <a:avLst/>
+          </a:prstGeom>
+          <a:noFill/>
+        </p:spPr>
+        <p:txBody>
+          <a:bodyPr wrap="none">
+            <a:spAutoFit/>
+          </a:bodyPr>
+          <a:lstStyle/>
+          <a:p>
+            <a:r>
+              <a:rPr sz="1100">
+                <a:solidFill>
+                  <a:srgbClr val="5B6B78"/>
+                </a:solidFill>
+              </a:rPr>
+              <a:t>Readiness gauges, risk charts, and clean presentation visuals inside the app.</a:t>
+            </a:r>
+          </a:p>
+        </p:txBody>
+      </p:sp>
+      <p:sp>
+        <p:nvSpPr>
+          <p:cNvPr id="20" name="Rounded Rectangle 19"/>
+          <p:cNvSpPr/>
+          <p:nvPr/>
+        </p:nvSpPr>
+        <p:spPr>
+          <a:xfrm>
+            <a:off x="731520" y="4069080"/>
+            <a:ext cx="5212080" cy="1051560"/>
+          </a:xfrm>
+          <a:prstGeom prst="roundRect">
+            <a:avLst/>
+          </a:prstGeom>
+          <a:solidFill>
+            <a:srgbClr val="FFFFFF"/>
+          </a:solidFill>
+          <a:ln w="12700">
+            <a:solidFill>
+              <a:srgbClr val="D6DFE5"/>
+            </a:solidFill>
+          </a:ln>
+        </p:spPr>
+        <p:style>
+          <a:lnRef idx="1">
+            <a:schemeClr val="accent1"/>
+          </a:lnRef>
+          <a:fillRef idx="3">
+            <a:schemeClr val="accent1"/>
+          </a:fillRef>
+          <a:effectRef idx="2">
+            <a:schemeClr val="accent1"/>
+          </a:effectRef>
+          <a:fontRef idx="minor">
+            <a:schemeClr val="lt1"/>
+          </a:fontRef>
+        </p:style>
+        <p:txBody>
+          <a:bodyPr rtlCol="0" anchor="ctr"/>
+          <a:lstStyle/>
+          <a:p>
+            <a:pPr algn="ctr"/>
+          </a:p>
+        </p:txBody>
+      </p:sp>
+      <p:sp>
+        <p:nvSpPr>
+          <p:cNvPr id="21" name="Rounded Rectangle 20"/>
+          <p:cNvSpPr/>
+          <p:nvPr/>
+        </p:nvSpPr>
+        <p:spPr>
+          <a:xfrm>
+            <a:off x="896112" y="4233672"/>
+            <a:ext cx="658368" cy="658368"/>
+          </a:xfrm>
+          <a:prstGeom prst="roundRect">
+            <a:avLst/>
+          </a:prstGeom>
+          <a:solidFill>
+            <a:srgbClr val="217346"/>
+          </a:solidFill>
+          <a:ln>
+            <a:solidFill>
+              <a:srgbClr val="217346"/>
+            </a:solidFill>
+          </a:ln>
+        </p:spPr>
+        <p:style>
+          <a:lnRef idx="1">
+            <a:schemeClr val="accent1"/>
+          </a:lnRef>
+          <a:fillRef idx="3">
+            <a:schemeClr val="accent1"/>
+          </a:fillRef>
+          <a:effectRef idx="2">
+            <a:schemeClr val="accent1"/>
+          </a:effectRef>
+          <a:fontRef idx="minor">
+            <a:schemeClr val="lt1"/>
+          </a:fontRef>
+        </p:style>
+        <p:txBody>
+          <a:bodyPr rtlCol="0" anchor="ctr"/>
+          <a:lstStyle/>
+          <a:p>
+            <a:pPr algn="ctr"/>
+            <a:r>
+              <a:rPr sz="1800" b="1">
+                <a:solidFill>
+                  <a:srgbClr val="FFFFFF"/>
+                </a:solidFill>
+              </a:rPr>
+              <a:t>xl</a:t>
+            </a:r>
+          </a:p>
+        </p:txBody>
+      </p:sp>
+      <p:sp>
+        <p:nvSpPr>
+          <p:cNvPr id="22" name="TextBox 21"/>
+          <p:cNvSpPr txBox="1"/>
+          <p:nvPr/>
+        </p:nvSpPr>
+        <p:spPr>
+          <a:xfrm>
+            <a:off x="1691640" y="4251960"/>
+            <a:ext cx="4069080" cy="274320"/>
+          </a:xfrm>
+          <a:prstGeom prst="rect">
+            <a:avLst/>
+          </a:prstGeom>
+          <a:noFill/>
+        </p:spPr>
+        <p:txBody>
+          <a:bodyPr wrap="none">
+            <a:spAutoFit/>
+          </a:bodyPr>
+          <a:lstStyle/>
+          <a:p>
+            <a:r>
+              <a:rPr sz="1600" b="1">
                 <a:solidFill>
                   <a:srgbClr val="0F1F2C"/>
                 </a:solidFill>
-              </a:defRPr>
-            </a:pPr>
-            <a:r>
-              <a:t>Journal Entry Agent: Builds ERP-ready accrual and reclass drafts with support and audit trails.</a:t>
-            </a:r>
-          </a:p>
-          <a:p>
-            <a:pPr>
-              <a:spcAft>
-                <a:spcPts val="800"/>
-              </a:spcAft>
-              <a:defRPr sz="1500">
+              </a:rPr>
+              <a:t>OpenPyXL / Excel</a:t>
+            </a:r>
+          </a:p>
+        </p:txBody>
+      </p:sp>
+      <p:sp>
+        <p:nvSpPr>
+          <p:cNvPr id="23" name="TextBox 22"/>
+          <p:cNvSpPr txBox="1"/>
+          <p:nvPr/>
+        </p:nvSpPr>
+        <p:spPr>
+          <a:xfrm>
+            <a:off x="1691640" y="4572000"/>
+            <a:ext cx="4069080" cy="566928"/>
+          </a:xfrm>
+          <a:prstGeom prst="rect">
+            <a:avLst/>
+          </a:prstGeom>
+          <a:noFill/>
+        </p:spPr>
+        <p:txBody>
+          <a:bodyPr wrap="none">
+            <a:spAutoFit/>
+          </a:bodyPr>
+          <a:lstStyle/>
+          <a:p>
+            <a:r>
+              <a:rPr sz="1100">
+                <a:solidFill>
+                  <a:srgbClr val="5B6B78"/>
+                </a:solidFill>
+              </a:rPr>
+              <a:t>Reads the month-end workbook and preserves the finance-team operating model.</a:t>
+            </a:r>
+          </a:p>
+        </p:txBody>
+      </p:sp>
+      <p:sp>
+        <p:nvSpPr>
+          <p:cNvPr id="24" name="Rounded Rectangle 23"/>
+          <p:cNvSpPr/>
+          <p:nvPr/>
+        </p:nvSpPr>
+        <p:spPr>
+          <a:xfrm>
+            <a:off x="6080760" y="4069080"/>
+            <a:ext cx="5212080" cy="1051560"/>
+          </a:xfrm>
+          <a:prstGeom prst="roundRect">
+            <a:avLst/>
+          </a:prstGeom>
+          <a:solidFill>
+            <a:srgbClr val="FFFFFF"/>
+          </a:solidFill>
+          <a:ln w="12700">
+            <a:solidFill>
+              <a:srgbClr val="D6DFE5"/>
+            </a:solidFill>
+          </a:ln>
+        </p:spPr>
+        <p:style>
+          <a:lnRef idx="1">
+            <a:schemeClr val="accent1"/>
+          </a:lnRef>
+          <a:fillRef idx="3">
+            <a:schemeClr val="accent1"/>
+          </a:fillRef>
+          <a:effectRef idx="2">
+            <a:schemeClr val="accent1"/>
+          </a:effectRef>
+          <a:fontRef idx="minor">
+            <a:schemeClr val="lt1"/>
+          </a:fontRef>
+        </p:style>
+        <p:txBody>
+          <a:bodyPr rtlCol="0" anchor="ctr"/>
+          <a:lstStyle/>
+          <a:p>
+            <a:pPr algn="ctr"/>
+          </a:p>
+        </p:txBody>
+      </p:sp>
+      <p:sp>
+        <p:nvSpPr>
+          <p:cNvPr id="25" name="Rounded Rectangle 24"/>
+          <p:cNvSpPr/>
+          <p:nvPr/>
+        </p:nvSpPr>
+        <p:spPr>
+          <a:xfrm>
+            <a:off x="6245352" y="4233672"/>
+            <a:ext cx="658368" cy="658368"/>
+          </a:xfrm>
+          <a:prstGeom prst="roundRect">
+            <a:avLst/>
+          </a:prstGeom>
+          <a:solidFill>
+            <a:srgbClr val="7353E5"/>
+          </a:solidFill>
+          <a:ln>
+            <a:solidFill>
+              <a:srgbClr val="7353E5"/>
+            </a:solidFill>
+          </a:ln>
+        </p:spPr>
+        <p:style>
+          <a:lnRef idx="1">
+            <a:schemeClr val="accent1"/>
+          </a:lnRef>
+          <a:fillRef idx="3">
+            <a:schemeClr val="accent1"/>
+          </a:fillRef>
+          <a:effectRef idx="2">
+            <a:schemeClr val="accent1"/>
+          </a:effectRef>
+          <a:fontRef idx="minor">
+            <a:schemeClr val="lt1"/>
+          </a:fontRef>
+        </p:style>
+        <p:txBody>
+          <a:bodyPr rtlCol="0" anchor="ctr"/>
+          <a:lstStyle/>
+          <a:p>
+            <a:pPr algn="ctr"/>
+            <a:r>
+              <a:rPr sz="1800" b="1">
+                <a:solidFill>
+                  <a:srgbClr val="FFFFFF"/>
+                </a:solidFill>
+              </a:rPr>
+              <a:t>AI</a:t>
+            </a:r>
+          </a:p>
+        </p:txBody>
+      </p:sp>
+      <p:sp>
+        <p:nvSpPr>
+          <p:cNvPr id="26" name="TextBox 25"/>
+          <p:cNvSpPr txBox="1"/>
+          <p:nvPr/>
+        </p:nvSpPr>
+        <p:spPr>
+          <a:xfrm>
+            <a:off x="7040880" y="4251960"/>
+            <a:ext cx="4069080" cy="274320"/>
+          </a:xfrm>
+          <a:prstGeom prst="rect">
+            <a:avLst/>
+          </a:prstGeom>
+          <a:noFill/>
+        </p:spPr>
+        <p:txBody>
+          <a:bodyPr wrap="none">
+            <a:spAutoFit/>
+          </a:bodyPr>
+          <a:lstStyle/>
+          <a:p>
+            <a:r>
+              <a:rPr sz="1600" b="1">
                 <a:solidFill>
                   <a:srgbClr val="0F1F2C"/>
                 </a:solidFill>
-              </a:defRPr>
-            </a:pPr>
-            <a:r>
-              <a:t>Audit &amp; Compliance Agent: Scores control completeness and separates ready-to-post from held entries.</a:t>
-            </a:r>
-          </a:p>
-          <a:p>
-            <a:pPr>
-              <a:spcAft>
-                <a:spcPts val="800"/>
-              </a:spcAft>
-              <a:defRPr sz="1500">
-                <a:solidFill>
-                  <a:srgbClr val="0F1F2C"/>
-                </a:solidFill>
-              </a:defRPr>
-            </a:pPr>
-            <a:r>
-              <a:t>Variance Analysis Agent: Calculates MoM and YoY anomalies and drafts executive commentary.</a:t>
-            </a:r>
-          </a:p>
-          <a:p>
-            <a:pPr>
-              <a:spcAft>
-                <a:spcPts val="800"/>
-              </a:spcAft>
-              <a:defRPr sz="1500">
-                <a:solidFill>
-                  <a:srgbClr val="0F1F2C"/>
-                </a:solidFill>
-              </a:defRPr>
-            </a:pPr>
-            <a:r>
-              <a:t>Close Tracker: Turns checklist dependencies into an unblock queue with critical-path visibility.</a:t>
-            </a:r>
-          </a:p>
-        </p:txBody>
-      </p:sp>
-      <p:sp>
-        <p:nvSpPr>
-          <p:cNvPr id="6" name="TextBox 5"/>
+              </a:rPr>
+              <a:t>Local AI Copilot Logic</a:t>
+            </a:r>
+          </a:p>
+        </p:txBody>
+      </p:sp>
+      <p:sp>
+        <p:nvSpPr>
+          <p:cNvPr id="27" name="TextBox 26"/>
+          <p:cNvSpPr txBox="1"/>
+          <p:nvPr/>
+        </p:nvSpPr>
+        <p:spPr>
+          <a:xfrm>
+            <a:off x="7040880" y="4572000"/>
+            <a:ext cx="4069080" cy="566928"/>
+          </a:xfrm>
+          <a:prstGeom prst="rect">
+            <a:avLst/>
+          </a:prstGeom>
+          <a:noFill/>
+        </p:spPr>
+        <p:txBody>
+          <a:bodyPr wrap="none">
+            <a:spAutoFit/>
+          </a:bodyPr>
+          <a:lstStyle/>
+          <a:p>
+            <a:r>
+              <a:rPr sz="1100">
+                <a:solidFill>
+                  <a:srgbClr val="5B6B78"/>
+                </a:solidFill>
+              </a:rPr>
+              <a:t>Deterministic prompt routing, commentary drafting, and finance-ready narrative outputs.</a:t>
+            </a:r>
+          </a:p>
+        </p:txBody>
+      </p:sp>
+      <p:sp>
+        <p:nvSpPr>
+          <p:cNvPr id="28" name="TextBox 27"/>
           <p:cNvSpPr txBox="1"/>
           <p:nvPr/>
         </p:nvSpPr>
@@ -7301,7 +8125,7 @@
                   <a:srgbClr val="5B6B78"/>
                 </a:solidFill>
               </a:rPr>
-              <a:t>NovaClose | Agent architecture</a:t>
+              <a:t>NovaClose | Build stack</a:t>
             </a:r>
           </a:p>
         </p:txBody>
@@ -7360,7 +8184,7 @@
                   <a:srgbClr val="0F1F2C"/>
                 </a:solidFill>
               </a:rPr>
-              <a:t>Automation bundle and control transparency</a:t>
+              <a:t>Agent suite</a:t>
             </a:r>
           </a:p>
         </p:txBody>
@@ -7393,7 +8217,7 @@
                   <a:srgbClr val="5B6B78"/>
                 </a:solidFill>
               </a:rPr>
-              <a:t>One controlled bundle runs in the app, with an audit trail on what changed and what still needs release.</a:t>
+              <a:t>Each agent owns a specific part of the close and feeds a common readiness and posting model.</a:t>
             </a:r>
           </a:p>
         </p:txBody>
@@ -7406,8 +8230,8 @@
         </p:nvSpPr>
         <p:spPr>
           <a:xfrm>
-            <a:off x="685800" y="1325880"/>
-            <a:ext cx="6400800" cy="274320"/>
+            <a:off x="731520" y="1371600"/>
+            <a:ext cx="10972800" cy="274320"/>
           </a:xfrm>
           <a:prstGeom prst="rect">
             <a:avLst/>
@@ -7426,7 +8250,7 @@
                   <a:srgbClr val="5B6B78"/>
                 </a:solidFill>
               </a:rPr>
-              <a:t>BUNDLE ACTIONS</a:t>
+              <a:t>WHAT MOVED OUT OF THE UI AND INTO THE DECK</a:t>
             </a:r>
           </a:p>
         </p:txBody>
@@ -7439,8 +8263,8 @@
         </p:nvSpPr>
         <p:spPr>
           <a:xfrm>
-            <a:off x="685800" y="1600200"/>
-            <a:ext cx="6400800" cy="4114800"/>
+            <a:off x="731520" y="1645920"/>
+            <a:ext cx="10972800" cy="4754880"/>
           </a:xfrm>
           <a:prstGeom prst="rect">
             <a:avLst/>
@@ -7464,7 +8288,7 @@
               </a:defRPr>
             </a:pPr>
             <a:r>
-              <a:t>1. Auto-approve 16 straight-through journals</a:t>
+              <a:t>GL Approval Agent: Triages pending journals into straight-through, manager, controller, and CFO lanes.</a:t>
             </a:r>
           </a:p>
           <a:p>
@@ -7479,7 +8303,7 @@
               </a:defRPr>
             </a:pPr>
             <a:r>
-              <a:t>2. Fast-track manager and controller approval packets</a:t>
+              <a:t>Bank Reconciliation Agent: Routes cash exceptions, drafts residual journals, and isolates statement breaks.</a:t>
             </a:r>
           </a:p>
           <a:p>
@@ -7494,7 +8318,7 @@
               </a:defRPr>
             </a:pPr>
             <a:r>
-              <a:t>3. Clear 3 timing items and post 2 bank drafts</a:t>
+              <a:t>IC Reconciliation Agent: Auto-matches counterparties, resolves FX mismatches, and drafts eliminations.</a:t>
             </a:r>
           </a:p>
           <a:p>
@@ -7509,7 +8333,7 @@
               </a:defRPr>
             </a:pPr>
             <a:r>
-              <a:t>4. Post 2 IC elimination drafts and clear matched pairs</a:t>
+              <a:t>Journal Entry Agent: Builds ERP-ready accrual and reclass drafts with support and audit trails.</a:t>
             </a:r>
           </a:p>
           <a:p>
@@ -7524,7 +8348,7 @@
               </a:defRPr>
             </a:pPr>
             <a:r>
-              <a:t>5. Post 7 ERP-ready journal drafts</a:t>
+              <a:t>Audit &amp; Compliance Agent: Scores control completeness and separates ready-to-post from held entries.</a:t>
             </a:r>
           </a:p>
           <a:p>
@@ -7539,7 +8363,7 @@
               </a:defRPr>
             </a:pPr>
             <a:r>
-              <a:t>6. Auto-release blocked checklist handoffs (7 hrs recoverable)</a:t>
+              <a:t>Variance Analysis Agent: Calculates MoM and YoY anomalies and drafts executive commentary.</a:t>
             </a:r>
           </a:p>
           <a:p>
@@ -7554,647 +8378,14 @@
               </a:defRPr>
             </a:pPr>
             <a:r>
-              <a:t>7. Sweep low-risk AP matching exceptions</a:t>
-            </a:r>
-          </a:p>
-        </p:txBody>
-      </p:sp>
-      <p:sp>
-        <p:nvSpPr>
-          <p:cNvPr id="6" name="Rounded Rectangle 5"/>
-          <p:cNvSpPr/>
-          <p:nvPr/>
-        </p:nvSpPr>
-        <p:spPr>
-          <a:xfrm>
-            <a:off x="7589520" y="1417320"/>
-            <a:ext cx="1828800" cy="1280160"/>
-          </a:xfrm>
-          <a:prstGeom prst="roundRect">
-            <a:avLst/>
-          </a:prstGeom>
-          <a:solidFill>
-            <a:srgbClr val="FFFFFF"/>
-          </a:solidFill>
-          <a:ln w="12700">
-            <a:solidFill>
-              <a:srgbClr val="D6DFE5"/>
-            </a:solidFill>
-          </a:ln>
-        </p:spPr>
-        <p:style>
-          <a:lnRef idx="1">
-            <a:schemeClr val="accent1"/>
-          </a:lnRef>
-          <a:fillRef idx="3">
-            <a:schemeClr val="accent1"/>
-          </a:fillRef>
-          <a:effectRef idx="2">
-            <a:schemeClr val="accent1"/>
-          </a:effectRef>
-          <a:fontRef idx="minor">
-            <a:schemeClr val="lt1"/>
-          </a:fontRef>
-        </p:style>
-        <p:txBody>
-          <a:bodyPr rtlCol="0" anchor="ctr"/>
-          <a:lstStyle/>
-          <a:p>
-            <a:pPr algn="ctr"/>
-          </a:p>
-        </p:txBody>
-      </p:sp>
-      <p:sp>
-        <p:nvSpPr>
-          <p:cNvPr id="7" name="TextBox 6"/>
-          <p:cNvSpPr txBox="1"/>
-          <p:nvPr/>
-        </p:nvSpPr>
-        <p:spPr>
-          <a:xfrm>
-            <a:off x="7735824" y="1508760"/>
-            <a:ext cx="1554480" cy="228600"/>
-          </a:xfrm>
-          <a:prstGeom prst="rect">
-            <a:avLst/>
-          </a:prstGeom>
-          <a:noFill/>
-        </p:spPr>
-        <p:txBody>
-          <a:bodyPr wrap="none">
-            <a:spAutoFit/>
-          </a:bodyPr>
-          <a:lstStyle/>
-          <a:p>
-            <a:r>
-              <a:rPr sz="1000" b="1">
-                <a:solidFill>
-                  <a:srgbClr val="5B6B78"/>
-                </a:solidFill>
-              </a:rPr>
-              <a:t>AUTO-POST</a:t>
-            </a:r>
-          </a:p>
-        </p:txBody>
-      </p:sp>
-      <p:sp>
-        <p:nvSpPr>
-          <p:cNvPr id="8" name="TextBox 7"/>
-          <p:cNvSpPr txBox="1"/>
-          <p:nvPr/>
-        </p:nvSpPr>
-        <p:spPr>
-          <a:xfrm>
-            <a:off x="7735824" y="1801368"/>
-            <a:ext cx="1554480" cy="411480"/>
-          </a:xfrm>
-          <a:prstGeom prst="rect">
-            <a:avLst/>
-          </a:prstGeom>
-          <a:noFill/>
-        </p:spPr>
-        <p:txBody>
-          <a:bodyPr wrap="none">
-            <a:spAutoFit/>
-          </a:bodyPr>
-          <a:lstStyle/>
-          <a:p>
-            <a:pPr algn="ctr"/>
-            <a:r>
-              <a:rPr sz="2400" b="1">
-                <a:solidFill>
-                  <a:srgbClr val="2A9D8F"/>
-                </a:solidFill>
-              </a:rPr>
-              <a:t>26</a:t>
-            </a:r>
-          </a:p>
-        </p:txBody>
-      </p:sp>
-      <p:sp>
-        <p:nvSpPr>
-          <p:cNvPr id="9" name="TextBox 8"/>
-          <p:cNvSpPr txBox="1"/>
-          <p:nvPr/>
-        </p:nvSpPr>
-        <p:spPr>
-          <a:xfrm>
-            <a:off x="7735824" y="2258568"/>
-            <a:ext cx="1554480" cy="320040"/>
-          </a:xfrm>
-          <a:prstGeom prst="rect">
-            <a:avLst/>
-          </a:prstGeom>
-          <a:noFill/>
-        </p:spPr>
-        <p:txBody>
-          <a:bodyPr wrap="none">
-            <a:spAutoFit/>
-          </a:bodyPr>
-          <a:lstStyle/>
-          <a:p>
-            <a:r>
-              <a:rPr sz="1000">
-                <a:solidFill>
-                  <a:srgbClr val="5B6B78"/>
-                </a:solidFill>
-              </a:rPr>
-              <a:t>Moves straight into ERP when policy allows.</a:t>
-            </a:r>
-          </a:p>
-        </p:txBody>
-      </p:sp>
-      <p:sp>
-        <p:nvSpPr>
-          <p:cNvPr id="10" name="Rounded Rectangle 9"/>
-          <p:cNvSpPr/>
-          <p:nvPr/>
-        </p:nvSpPr>
-        <p:spPr>
-          <a:xfrm>
-            <a:off x="9555480" y="1417320"/>
-            <a:ext cx="1828800" cy="1280160"/>
-          </a:xfrm>
-          <a:prstGeom prst="roundRect">
-            <a:avLst/>
-          </a:prstGeom>
-          <a:solidFill>
-            <a:srgbClr val="FFFFFF"/>
-          </a:solidFill>
-          <a:ln w="12700">
-            <a:solidFill>
-              <a:srgbClr val="D6DFE5"/>
-            </a:solidFill>
-          </a:ln>
-        </p:spPr>
-        <p:style>
-          <a:lnRef idx="1">
-            <a:schemeClr val="accent1"/>
-          </a:lnRef>
-          <a:fillRef idx="3">
-            <a:schemeClr val="accent1"/>
-          </a:fillRef>
-          <a:effectRef idx="2">
-            <a:schemeClr val="accent1"/>
-          </a:effectRef>
-          <a:fontRef idx="minor">
-            <a:schemeClr val="lt1"/>
-          </a:fontRef>
-        </p:style>
-        <p:txBody>
-          <a:bodyPr rtlCol="0" anchor="ctr"/>
-          <a:lstStyle/>
-          <a:p>
-            <a:pPr algn="ctr"/>
-          </a:p>
-        </p:txBody>
-      </p:sp>
-      <p:sp>
-        <p:nvSpPr>
-          <p:cNvPr id="11" name="TextBox 10"/>
-          <p:cNvSpPr txBox="1"/>
-          <p:nvPr/>
-        </p:nvSpPr>
-        <p:spPr>
-          <a:xfrm>
-            <a:off x="9701784" y="1508760"/>
-            <a:ext cx="1554480" cy="228600"/>
-          </a:xfrm>
-          <a:prstGeom prst="rect">
-            <a:avLst/>
-          </a:prstGeom>
-          <a:noFill/>
-        </p:spPr>
-        <p:txBody>
-          <a:bodyPr wrap="none">
-            <a:spAutoFit/>
-          </a:bodyPr>
-          <a:lstStyle/>
-          <a:p>
-            <a:r>
-              <a:rPr sz="1000" b="1">
-                <a:solidFill>
-                  <a:srgbClr val="5B6B78"/>
-                </a:solidFill>
-              </a:rPr>
-              <a:t>READY TO POST</a:t>
-            </a:r>
-          </a:p>
-        </p:txBody>
-      </p:sp>
-      <p:sp>
-        <p:nvSpPr>
-          <p:cNvPr id="12" name="TextBox 11"/>
-          <p:cNvSpPr txBox="1"/>
-          <p:nvPr/>
-        </p:nvSpPr>
-        <p:spPr>
-          <a:xfrm>
-            <a:off x="9701784" y="1801368"/>
-            <a:ext cx="1554480" cy="411480"/>
-          </a:xfrm>
-          <a:prstGeom prst="rect">
-            <a:avLst/>
-          </a:prstGeom>
-          <a:noFill/>
-        </p:spPr>
-        <p:txBody>
-          <a:bodyPr wrap="none">
-            <a:spAutoFit/>
-          </a:bodyPr>
-          <a:lstStyle/>
-          <a:p>
-            <a:pPr algn="ctr"/>
-            <a:r>
-              <a:rPr sz="2400" b="1">
-                <a:solidFill>
-                  <a:srgbClr val="D77A2D"/>
-                </a:solidFill>
-              </a:rPr>
-              <a:t>65</a:t>
-            </a:r>
-          </a:p>
-        </p:txBody>
-      </p:sp>
-      <p:sp>
-        <p:nvSpPr>
-          <p:cNvPr id="13" name="TextBox 12"/>
-          <p:cNvSpPr txBox="1"/>
-          <p:nvPr/>
-        </p:nvSpPr>
-        <p:spPr>
-          <a:xfrm>
-            <a:off x="9701784" y="2258568"/>
-            <a:ext cx="1554480" cy="320040"/>
-          </a:xfrm>
-          <a:prstGeom prst="rect">
-            <a:avLst/>
-          </a:prstGeom>
-          <a:noFill/>
-        </p:spPr>
-        <p:txBody>
-          <a:bodyPr wrap="none">
-            <a:spAutoFit/>
-          </a:bodyPr>
-          <a:lstStyle/>
-          <a:p>
-            <a:r>
-              <a:rPr sz="1000">
-                <a:solidFill>
-                  <a:srgbClr val="5B6B78"/>
-                </a:solidFill>
-              </a:rPr>
-              <a:t>Cleared but still awaiting release.</a:t>
-            </a:r>
-          </a:p>
-        </p:txBody>
-      </p:sp>
-      <p:sp>
-        <p:nvSpPr>
-          <p:cNvPr id="14" name="Rounded Rectangle 13"/>
-          <p:cNvSpPr/>
-          <p:nvPr/>
-        </p:nvSpPr>
-        <p:spPr>
-          <a:xfrm>
-            <a:off x="7589520" y="2926080"/>
-            <a:ext cx="1828800" cy="1280160"/>
-          </a:xfrm>
-          <a:prstGeom prst="roundRect">
-            <a:avLst/>
-          </a:prstGeom>
-          <a:solidFill>
-            <a:srgbClr val="FFFFFF"/>
-          </a:solidFill>
-          <a:ln w="12700">
-            <a:solidFill>
-              <a:srgbClr val="D6DFE5"/>
-            </a:solidFill>
-          </a:ln>
-        </p:spPr>
-        <p:style>
-          <a:lnRef idx="1">
-            <a:schemeClr val="accent1"/>
-          </a:lnRef>
-          <a:fillRef idx="3">
-            <a:schemeClr val="accent1"/>
-          </a:fillRef>
-          <a:effectRef idx="2">
-            <a:schemeClr val="accent1"/>
-          </a:effectRef>
-          <a:fontRef idx="minor">
-            <a:schemeClr val="lt1"/>
-          </a:fontRef>
-        </p:style>
-        <p:txBody>
-          <a:bodyPr rtlCol="0" anchor="ctr"/>
-          <a:lstStyle/>
-          <a:p>
-            <a:pPr algn="ctr"/>
-          </a:p>
-        </p:txBody>
-      </p:sp>
-      <p:sp>
-        <p:nvSpPr>
-          <p:cNvPr id="15" name="TextBox 14"/>
-          <p:cNvSpPr txBox="1"/>
-          <p:nvPr/>
-        </p:nvSpPr>
-        <p:spPr>
-          <a:xfrm>
-            <a:off x="7735824" y="3017520"/>
-            <a:ext cx="1554480" cy="228600"/>
-          </a:xfrm>
-          <a:prstGeom prst="rect">
-            <a:avLst/>
-          </a:prstGeom>
-          <a:noFill/>
-        </p:spPr>
-        <p:txBody>
-          <a:bodyPr wrap="none">
-            <a:spAutoFit/>
-          </a:bodyPr>
-          <a:lstStyle/>
-          <a:p>
-            <a:r>
-              <a:rPr sz="1000" b="1">
-                <a:solidFill>
-                  <a:srgbClr val="5B6B78"/>
-                </a:solidFill>
-              </a:rPr>
-              <a:t>MANUAL HOLD</a:t>
-            </a:r>
-          </a:p>
-        </p:txBody>
-      </p:sp>
-      <p:sp>
-        <p:nvSpPr>
-          <p:cNvPr id="16" name="TextBox 15"/>
-          <p:cNvSpPr txBox="1"/>
-          <p:nvPr/>
-        </p:nvSpPr>
-        <p:spPr>
-          <a:xfrm>
-            <a:off x="7735824" y="3310128"/>
-            <a:ext cx="1554480" cy="411480"/>
-          </a:xfrm>
-          <a:prstGeom prst="rect">
-            <a:avLst/>
-          </a:prstGeom>
-          <a:noFill/>
-        </p:spPr>
-        <p:txBody>
-          <a:bodyPr wrap="none">
-            <a:spAutoFit/>
-          </a:bodyPr>
-          <a:lstStyle/>
-          <a:p>
-            <a:pPr algn="ctr"/>
-            <a:r>
-              <a:rPr sz="2400" b="1">
-                <a:solidFill>
-                  <a:srgbClr val="C75C5C"/>
-                </a:solidFill>
-              </a:rPr>
-              <a:t>91</a:t>
-            </a:r>
-          </a:p>
-        </p:txBody>
-      </p:sp>
-      <p:sp>
-        <p:nvSpPr>
-          <p:cNvPr id="17" name="TextBox 16"/>
-          <p:cNvSpPr txBox="1"/>
-          <p:nvPr/>
-        </p:nvSpPr>
-        <p:spPr>
-          <a:xfrm>
-            <a:off x="7735824" y="3767328"/>
-            <a:ext cx="1554480" cy="320040"/>
-          </a:xfrm>
-          <a:prstGeom prst="rect">
-            <a:avLst/>
-          </a:prstGeom>
-          <a:noFill/>
-        </p:spPr>
-        <p:txBody>
-          <a:bodyPr wrap="none">
-            <a:spAutoFit/>
-          </a:bodyPr>
-          <a:lstStyle/>
-          <a:p>
-            <a:r>
-              <a:rPr sz="1000">
-                <a:solidFill>
-                  <a:srgbClr val="5B6B78"/>
-                </a:solidFill>
-              </a:rPr>
-              <a:t>Still requires review or approval.</a:t>
-            </a:r>
-          </a:p>
-        </p:txBody>
-      </p:sp>
-      <p:sp>
-        <p:nvSpPr>
-          <p:cNvPr id="18" name="Rounded Rectangle 17"/>
-          <p:cNvSpPr/>
-          <p:nvPr/>
-        </p:nvSpPr>
-        <p:spPr>
-          <a:xfrm>
-            <a:off x="9555480" y="2926080"/>
-            <a:ext cx="1828800" cy="1280160"/>
-          </a:xfrm>
-          <a:prstGeom prst="roundRect">
-            <a:avLst/>
-          </a:prstGeom>
-          <a:solidFill>
-            <a:srgbClr val="FFFFFF"/>
-          </a:solidFill>
-          <a:ln w="12700">
-            <a:solidFill>
-              <a:srgbClr val="D6DFE5"/>
-            </a:solidFill>
-          </a:ln>
-        </p:spPr>
-        <p:style>
-          <a:lnRef idx="1">
-            <a:schemeClr val="accent1"/>
-          </a:lnRef>
-          <a:fillRef idx="3">
-            <a:schemeClr val="accent1"/>
-          </a:fillRef>
-          <a:effectRef idx="2">
-            <a:schemeClr val="accent1"/>
-          </a:effectRef>
-          <a:fontRef idx="minor">
-            <a:schemeClr val="lt1"/>
-          </a:fontRef>
-        </p:style>
-        <p:txBody>
-          <a:bodyPr rtlCol="0" anchor="ctr"/>
-          <a:lstStyle/>
-          <a:p>
-            <a:pPr algn="ctr"/>
-          </a:p>
-        </p:txBody>
-      </p:sp>
-      <p:sp>
-        <p:nvSpPr>
-          <p:cNvPr id="19" name="TextBox 18"/>
-          <p:cNvSpPr txBox="1"/>
-          <p:nvPr/>
-        </p:nvSpPr>
-        <p:spPr>
-          <a:xfrm>
-            <a:off x="9701784" y="3017520"/>
-            <a:ext cx="1554480" cy="228600"/>
-          </a:xfrm>
-          <a:prstGeom prst="rect">
-            <a:avLst/>
-          </a:prstGeom>
-          <a:noFill/>
-        </p:spPr>
-        <p:txBody>
-          <a:bodyPr wrap="none">
-            <a:spAutoFit/>
-          </a:bodyPr>
-          <a:lstStyle/>
-          <a:p>
-            <a:r>
-              <a:rPr sz="1000" b="1">
-                <a:solidFill>
-                  <a:srgbClr val="5B6B78"/>
-                </a:solidFill>
-              </a:rPr>
-              <a:t>HOURS SAVED</a:t>
-            </a:r>
-          </a:p>
-        </p:txBody>
-      </p:sp>
-      <p:sp>
-        <p:nvSpPr>
-          <p:cNvPr id="20" name="TextBox 19"/>
-          <p:cNvSpPr txBox="1"/>
-          <p:nvPr/>
-        </p:nvSpPr>
-        <p:spPr>
-          <a:xfrm>
-            <a:off x="9701784" y="3310128"/>
-            <a:ext cx="1554480" cy="411480"/>
-          </a:xfrm>
-          <a:prstGeom prst="rect">
-            <a:avLst/>
-          </a:prstGeom>
-          <a:noFill/>
-        </p:spPr>
-        <p:txBody>
-          <a:bodyPr wrap="none">
-            <a:spAutoFit/>
-          </a:bodyPr>
-          <a:lstStyle/>
-          <a:p>
-            <a:pPr algn="ctr"/>
-            <a:r>
-              <a:rPr sz="2400" b="1">
-                <a:solidFill>
-                  <a:srgbClr val="2A9D8F"/>
-                </a:solidFill>
-              </a:rPr>
-              <a:t>41</a:t>
-            </a:r>
-          </a:p>
-        </p:txBody>
-      </p:sp>
-      <p:sp>
-        <p:nvSpPr>
-          <p:cNvPr id="21" name="TextBox 20"/>
-          <p:cNvSpPr txBox="1"/>
-          <p:nvPr/>
-        </p:nvSpPr>
-        <p:spPr>
-          <a:xfrm>
-            <a:off x="9701784" y="3767328"/>
-            <a:ext cx="1554480" cy="320040"/>
-          </a:xfrm>
-          <a:prstGeom prst="rect">
-            <a:avLst/>
-          </a:prstGeom>
-          <a:noFill/>
-        </p:spPr>
-        <p:txBody>
-          <a:bodyPr wrap="none">
-            <a:spAutoFit/>
-          </a:bodyPr>
-          <a:lstStyle/>
-          <a:p>
-            <a:r>
-              <a:rPr sz="1000">
-                <a:solidFill>
-                  <a:srgbClr val="5B6B78"/>
-                </a:solidFill>
-              </a:rPr>
-              <a:t>Recovered from the automation bundle.</a:t>
-            </a:r>
-          </a:p>
-        </p:txBody>
-      </p:sp>
-      <p:sp>
-        <p:nvSpPr>
-          <p:cNvPr id="22" name="TextBox 21"/>
-          <p:cNvSpPr txBox="1"/>
-          <p:nvPr/>
-        </p:nvSpPr>
-        <p:spPr>
-          <a:xfrm>
-            <a:off x="7360920" y="4572000"/>
-            <a:ext cx="4114800" cy="1188720"/>
-          </a:xfrm>
-          <a:prstGeom prst="rect">
-            <a:avLst/>
-          </a:prstGeom>
-          <a:noFill/>
-        </p:spPr>
-        <p:txBody>
-          <a:bodyPr wrap="none">
-            <a:spAutoFit/>
-          </a:bodyPr>
-          <a:lstStyle/>
-          <a:p>
-            <a:pPr>
-              <a:spcAft>
-                <a:spcPts val="800"/>
-              </a:spcAft>
-              <a:defRPr sz="1500">
-                <a:solidFill>
-                  <a:srgbClr val="0F1F2C"/>
-                </a:solidFill>
-              </a:defRPr>
-            </a:pPr>
-            <a:r>
-              <a:t>Run sheet logs timestamps, actions applied, hours saved, and posting state.</a:t>
-            </a:r>
-          </a:p>
-          <a:p>
-            <a:pPr>
-              <a:spcAft>
-                <a:spcPts val="800"/>
-              </a:spcAft>
-              <a:defRPr sz="1500">
-                <a:solidFill>
-                  <a:srgbClr val="0F1F2C"/>
-                </a:solidFill>
-              </a:defRPr>
-            </a:pPr>
-            <a:r>
-              <a:t>Before/after risk cards and agent tables make the automation effect transparent.</a:t>
-            </a:r>
-          </a:p>
-        </p:txBody>
-      </p:sp>
-      <p:sp>
-        <p:nvSpPr>
-          <p:cNvPr id="23" name="TextBox 22"/>
+              <a:t>Close Tracker: Turns checklist dependencies into an unblock queue with critical-path visibility.</a:t>
+            </a:r>
+          </a:p>
+        </p:txBody>
+      </p:sp>
+      <p:sp>
+        <p:nvSpPr>
+          <p:cNvPr id="6" name="TextBox 5"/>
           <p:cNvSpPr txBox="1"/>
           <p:nvPr/>
         </p:nvSpPr>
@@ -8221,7 +8412,7 @@
                   <a:srgbClr val="5B6B78"/>
                 </a:solidFill>
               </a:rPr>
-              <a:t>NovaClose | Automation controls</a:t>
+              <a:t>NovaClose | Agent architecture</a:t>
             </a:r>
           </a:p>
         </p:txBody>
@@ -8280,7 +8471,7 @@
                   <a:srgbClr val="0F1F2C"/>
                 </a:solidFill>
               </a:rPr>
-              <a:t>How the CFO and operations team use it</a:t>
+              <a:t>Automation bundle and control transparency</a:t>
             </a:r>
           </a:p>
         </p:txBody>
@@ -8313,7 +8504,7 @@
                   <a:srgbClr val="5B6B78"/>
                 </a:solidFill>
               </a:rPr>
-              <a:t>The app is designed to answer three questions fast: Where are we? What moved? What do we do next?</a:t>
+              <a:t>One controlled bundle runs in the app, with an audit trail on what changed and what still needs release.</a:t>
             </a:r>
           </a:p>
         </p:txBody>
@@ -8326,8 +8517,8 @@
         </p:nvSpPr>
         <p:spPr>
           <a:xfrm>
-            <a:off x="731520" y="1417320"/>
-            <a:ext cx="5303520" cy="274320"/>
+            <a:off x="685800" y="1325880"/>
+            <a:ext cx="6400800" cy="274320"/>
           </a:xfrm>
           <a:prstGeom prst="rect">
             <a:avLst/>
@@ -8346,7 +8537,7 @@
                   <a:srgbClr val="5B6B78"/>
                 </a:solidFill>
               </a:rPr>
-              <a:t>OPERATOR FLOW</a:t>
+              <a:t>BUNDLE ACTIONS</a:t>
             </a:r>
           </a:p>
         </p:txBody>
@@ -8359,8 +8550,8 @@
         </p:nvSpPr>
         <p:spPr>
           <a:xfrm>
-            <a:off x="731520" y="1691640"/>
-            <a:ext cx="5303520" cy="4023360"/>
+            <a:off x="685800" y="1600200"/>
+            <a:ext cx="6400800" cy="4114800"/>
           </a:xfrm>
           <a:prstGeom prst="rect">
             <a:avLst/>
@@ -8384,7 +8575,7 @@
               </a:defRPr>
             </a:pPr>
             <a:r>
-              <a:t>1. Load the workbook and validate the period.</a:t>
+              <a:t>1. Auto-approve 16 straight-through journals</a:t>
             </a:r>
           </a:p>
           <a:p>
@@ -8399,7 +8590,7 @@
               </a:defRPr>
             </a:pPr>
             <a:r>
-              <a:t>2. Review the Command Centre before/after readiness signal.</a:t>
+              <a:t>2. Fast-track manager and controller approval packets</a:t>
             </a:r>
           </a:p>
           <a:p>
@@ -8414,7 +8605,7 @@
               </a:defRPr>
             </a:pPr>
             <a:r>
-              <a:t>3. Run the automation bundle from Month-End Steps.</a:t>
+              <a:t>3. Clear 3 timing items and post 2 bank drafts</a:t>
             </a:r>
           </a:p>
           <a:p>
@@ -8429,7 +8620,7 @@
               </a:defRPr>
             </a:pPr>
             <a:r>
-              <a:t>4. Work the top three priorities and owner queue.</a:t>
+              <a:t>4. Post 2 IC elimination drafts and clear matched pairs</a:t>
             </a:r>
           </a:p>
           <a:p>
@@ -8444,65 +8635,9 @@
               </a:defRPr>
             </a:pPr>
             <a:r>
-              <a:t>5. Use AI Copilot for blocker, entity, and variance questions.</a:t>
-            </a:r>
-          </a:p>
-        </p:txBody>
-      </p:sp>
-      <p:sp>
-        <p:nvSpPr>
-          <p:cNvPr id="6" name="TextBox 5"/>
-          <p:cNvSpPr txBox="1"/>
-          <p:nvPr/>
-        </p:nvSpPr>
-        <p:spPr>
-          <a:xfrm>
-            <a:off x="6217920" y="1417320"/>
-            <a:ext cx="5212080" cy="274320"/>
-          </a:xfrm>
-          <a:prstGeom prst="rect">
-            <a:avLst/>
-          </a:prstGeom>
-          <a:noFill/>
-        </p:spPr>
-        <p:txBody>
-          <a:bodyPr wrap="none">
-            <a:spAutoFit/>
-          </a:bodyPr>
-          <a:lstStyle/>
-          <a:p>
-            <a:r>
-              <a:rPr sz="1000" b="1">
-                <a:solidFill>
-                  <a:srgbClr val="5B6B78"/>
-                </a:solidFill>
-              </a:rPr>
-              <a:t>TOP FOCUS AREAS FROM THE CURRENT DATA</a:t>
-            </a:r>
-          </a:p>
-        </p:txBody>
-      </p:sp>
-      <p:sp>
-        <p:nvSpPr>
-          <p:cNvPr id="7" name="TextBox 6"/>
-          <p:cNvSpPr txBox="1"/>
-          <p:nvPr/>
-        </p:nvSpPr>
-        <p:spPr>
-          <a:xfrm>
-            <a:off x="6217920" y="1691640"/>
-            <a:ext cx="5212080" cy="4023360"/>
-          </a:xfrm>
-          <a:prstGeom prst="rect">
-            <a:avLst/>
-          </a:prstGeom>
-          <a:noFill/>
-        </p:spPr>
-        <p:txBody>
-          <a:bodyPr wrap="none">
-            <a:spAutoFit/>
-          </a:bodyPr>
-          <a:lstStyle/>
+              <a:t>5. Post 7 ERP-ready journal drafts</a:t>
+            </a:r>
+          </a:p>
           <a:p>
             <a:pPr>
               <a:spcAft>
@@ -8515,7 +8650,7 @@
               </a:defRPr>
             </a:pPr>
             <a:r>
-              <a:t>Clear pending GL reviews and approvals - Final account review and downstream controller sign-off</a:t>
+              <a:t>6. Auto-release blocked checklist handoffs (7 hrs recoverable)</a:t>
             </a:r>
           </a:p>
           <a:p>
@@ -8530,9 +8665,612 @@
               </a:defRPr>
             </a:pPr>
             <a:r>
-              <a:t>Resolve bank reconciliation exceptions - Cash certification and treasury close readiness</a:t>
-            </a:r>
-          </a:p>
+              <a:t>7. Sweep low-risk AP matching exceptions</a:t>
+            </a:r>
+          </a:p>
+        </p:txBody>
+      </p:sp>
+      <p:sp>
+        <p:nvSpPr>
+          <p:cNvPr id="6" name="Rounded Rectangle 5"/>
+          <p:cNvSpPr/>
+          <p:nvPr/>
+        </p:nvSpPr>
+        <p:spPr>
+          <a:xfrm>
+            <a:off x="7589520" y="1417320"/>
+            <a:ext cx="1828800" cy="1280160"/>
+          </a:xfrm>
+          <a:prstGeom prst="roundRect">
+            <a:avLst/>
+          </a:prstGeom>
+          <a:solidFill>
+            <a:srgbClr val="FFFFFF"/>
+          </a:solidFill>
+          <a:ln w="12700">
+            <a:solidFill>
+              <a:srgbClr val="D6DFE5"/>
+            </a:solidFill>
+          </a:ln>
+        </p:spPr>
+        <p:style>
+          <a:lnRef idx="1">
+            <a:schemeClr val="accent1"/>
+          </a:lnRef>
+          <a:fillRef idx="3">
+            <a:schemeClr val="accent1"/>
+          </a:fillRef>
+          <a:effectRef idx="2">
+            <a:schemeClr val="accent1"/>
+          </a:effectRef>
+          <a:fontRef idx="minor">
+            <a:schemeClr val="lt1"/>
+          </a:fontRef>
+        </p:style>
+        <p:txBody>
+          <a:bodyPr rtlCol="0" anchor="ctr"/>
+          <a:lstStyle/>
+          <a:p>
+            <a:pPr algn="ctr"/>
+          </a:p>
+        </p:txBody>
+      </p:sp>
+      <p:sp>
+        <p:nvSpPr>
+          <p:cNvPr id="7" name="TextBox 6"/>
+          <p:cNvSpPr txBox="1"/>
+          <p:nvPr/>
+        </p:nvSpPr>
+        <p:spPr>
+          <a:xfrm>
+            <a:off x="7735824" y="1508760"/>
+            <a:ext cx="1554480" cy="228600"/>
+          </a:xfrm>
+          <a:prstGeom prst="rect">
+            <a:avLst/>
+          </a:prstGeom>
+          <a:noFill/>
+        </p:spPr>
+        <p:txBody>
+          <a:bodyPr wrap="none">
+            <a:spAutoFit/>
+          </a:bodyPr>
+          <a:lstStyle/>
+          <a:p>
+            <a:r>
+              <a:rPr sz="1000" b="1">
+                <a:solidFill>
+                  <a:srgbClr val="5B6B78"/>
+                </a:solidFill>
+              </a:rPr>
+              <a:t>AUTO-POST</a:t>
+            </a:r>
+          </a:p>
+        </p:txBody>
+      </p:sp>
+      <p:sp>
+        <p:nvSpPr>
+          <p:cNvPr id="8" name="TextBox 7"/>
+          <p:cNvSpPr txBox="1"/>
+          <p:nvPr/>
+        </p:nvSpPr>
+        <p:spPr>
+          <a:xfrm>
+            <a:off x="7735824" y="1801368"/>
+            <a:ext cx="1554480" cy="411480"/>
+          </a:xfrm>
+          <a:prstGeom prst="rect">
+            <a:avLst/>
+          </a:prstGeom>
+          <a:noFill/>
+        </p:spPr>
+        <p:txBody>
+          <a:bodyPr wrap="none">
+            <a:spAutoFit/>
+          </a:bodyPr>
+          <a:lstStyle/>
+          <a:p>
+            <a:pPr algn="ctr"/>
+            <a:r>
+              <a:rPr sz="2400" b="1">
+                <a:solidFill>
+                  <a:srgbClr val="2A9D8F"/>
+                </a:solidFill>
+              </a:rPr>
+              <a:t>26</a:t>
+            </a:r>
+          </a:p>
+        </p:txBody>
+      </p:sp>
+      <p:sp>
+        <p:nvSpPr>
+          <p:cNvPr id="9" name="TextBox 8"/>
+          <p:cNvSpPr txBox="1"/>
+          <p:nvPr/>
+        </p:nvSpPr>
+        <p:spPr>
+          <a:xfrm>
+            <a:off x="7735824" y="2258568"/>
+            <a:ext cx="1554480" cy="320040"/>
+          </a:xfrm>
+          <a:prstGeom prst="rect">
+            <a:avLst/>
+          </a:prstGeom>
+          <a:noFill/>
+        </p:spPr>
+        <p:txBody>
+          <a:bodyPr wrap="none">
+            <a:spAutoFit/>
+          </a:bodyPr>
+          <a:lstStyle/>
+          <a:p>
+            <a:r>
+              <a:rPr sz="1000">
+                <a:solidFill>
+                  <a:srgbClr val="5B6B78"/>
+                </a:solidFill>
+              </a:rPr>
+              <a:t>Moves straight into ERP when policy allows.</a:t>
+            </a:r>
+          </a:p>
+        </p:txBody>
+      </p:sp>
+      <p:sp>
+        <p:nvSpPr>
+          <p:cNvPr id="10" name="Rounded Rectangle 9"/>
+          <p:cNvSpPr/>
+          <p:nvPr/>
+        </p:nvSpPr>
+        <p:spPr>
+          <a:xfrm>
+            <a:off x="9555480" y="1417320"/>
+            <a:ext cx="1828800" cy="1280160"/>
+          </a:xfrm>
+          <a:prstGeom prst="roundRect">
+            <a:avLst/>
+          </a:prstGeom>
+          <a:solidFill>
+            <a:srgbClr val="FFFFFF"/>
+          </a:solidFill>
+          <a:ln w="12700">
+            <a:solidFill>
+              <a:srgbClr val="D6DFE5"/>
+            </a:solidFill>
+          </a:ln>
+        </p:spPr>
+        <p:style>
+          <a:lnRef idx="1">
+            <a:schemeClr val="accent1"/>
+          </a:lnRef>
+          <a:fillRef idx="3">
+            <a:schemeClr val="accent1"/>
+          </a:fillRef>
+          <a:effectRef idx="2">
+            <a:schemeClr val="accent1"/>
+          </a:effectRef>
+          <a:fontRef idx="minor">
+            <a:schemeClr val="lt1"/>
+          </a:fontRef>
+        </p:style>
+        <p:txBody>
+          <a:bodyPr rtlCol="0" anchor="ctr"/>
+          <a:lstStyle/>
+          <a:p>
+            <a:pPr algn="ctr"/>
+          </a:p>
+        </p:txBody>
+      </p:sp>
+      <p:sp>
+        <p:nvSpPr>
+          <p:cNvPr id="11" name="TextBox 10"/>
+          <p:cNvSpPr txBox="1"/>
+          <p:nvPr/>
+        </p:nvSpPr>
+        <p:spPr>
+          <a:xfrm>
+            <a:off x="9701784" y="1508760"/>
+            <a:ext cx="1554480" cy="228600"/>
+          </a:xfrm>
+          <a:prstGeom prst="rect">
+            <a:avLst/>
+          </a:prstGeom>
+          <a:noFill/>
+        </p:spPr>
+        <p:txBody>
+          <a:bodyPr wrap="none">
+            <a:spAutoFit/>
+          </a:bodyPr>
+          <a:lstStyle/>
+          <a:p>
+            <a:r>
+              <a:rPr sz="1000" b="1">
+                <a:solidFill>
+                  <a:srgbClr val="5B6B78"/>
+                </a:solidFill>
+              </a:rPr>
+              <a:t>READY TO POST</a:t>
+            </a:r>
+          </a:p>
+        </p:txBody>
+      </p:sp>
+      <p:sp>
+        <p:nvSpPr>
+          <p:cNvPr id="12" name="TextBox 11"/>
+          <p:cNvSpPr txBox="1"/>
+          <p:nvPr/>
+        </p:nvSpPr>
+        <p:spPr>
+          <a:xfrm>
+            <a:off x="9701784" y="1801368"/>
+            <a:ext cx="1554480" cy="411480"/>
+          </a:xfrm>
+          <a:prstGeom prst="rect">
+            <a:avLst/>
+          </a:prstGeom>
+          <a:noFill/>
+        </p:spPr>
+        <p:txBody>
+          <a:bodyPr wrap="none">
+            <a:spAutoFit/>
+          </a:bodyPr>
+          <a:lstStyle/>
+          <a:p>
+            <a:pPr algn="ctr"/>
+            <a:r>
+              <a:rPr sz="2400" b="1">
+                <a:solidFill>
+                  <a:srgbClr val="D77A2D"/>
+                </a:solidFill>
+              </a:rPr>
+              <a:t>65</a:t>
+            </a:r>
+          </a:p>
+        </p:txBody>
+      </p:sp>
+      <p:sp>
+        <p:nvSpPr>
+          <p:cNvPr id="13" name="TextBox 12"/>
+          <p:cNvSpPr txBox="1"/>
+          <p:nvPr/>
+        </p:nvSpPr>
+        <p:spPr>
+          <a:xfrm>
+            <a:off x="9701784" y="2258568"/>
+            <a:ext cx="1554480" cy="320040"/>
+          </a:xfrm>
+          <a:prstGeom prst="rect">
+            <a:avLst/>
+          </a:prstGeom>
+          <a:noFill/>
+        </p:spPr>
+        <p:txBody>
+          <a:bodyPr wrap="none">
+            <a:spAutoFit/>
+          </a:bodyPr>
+          <a:lstStyle/>
+          <a:p>
+            <a:r>
+              <a:rPr sz="1000">
+                <a:solidFill>
+                  <a:srgbClr val="5B6B78"/>
+                </a:solidFill>
+              </a:rPr>
+              <a:t>Cleared but still awaiting release.</a:t>
+            </a:r>
+          </a:p>
+        </p:txBody>
+      </p:sp>
+      <p:sp>
+        <p:nvSpPr>
+          <p:cNvPr id="14" name="Rounded Rectangle 13"/>
+          <p:cNvSpPr/>
+          <p:nvPr/>
+        </p:nvSpPr>
+        <p:spPr>
+          <a:xfrm>
+            <a:off x="7589520" y="2926080"/>
+            <a:ext cx="1828800" cy="1280160"/>
+          </a:xfrm>
+          <a:prstGeom prst="roundRect">
+            <a:avLst/>
+          </a:prstGeom>
+          <a:solidFill>
+            <a:srgbClr val="FFFFFF"/>
+          </a:solidFill>
+          <a:ln w="12700">
+            <a:solidFill>
+              <a:srgbClr val="D6DFE5"/>
+            </a:solidFill>
+          </a:ln>
+        </p:spPr>
+        <p:style>
+          <a:lnRef idx="1">
+            <a:schemeClr val="accent1"/>
+          </a:lnRef>
+          <a:fillRef idx="3">
+            <a:schemeClr val="accent1"/>
+          </a:fillRef>
+          <a:effectRef idx="2">
+            <a:schemeClr val="accent1"/>
+          </a:effectRef>
+          <a:fontRef idx="minor">
+            <a:schemeClr val="lt1"/>
+          </a:fontRef>
+        </p:style>
+        <p:txBody>
+          <a:bodyPr rtlCol="0" anchor="ctr"/>
+          <a:lstStyle/>
+          <a:p>
+            <a:pPr algn="ctr"/>
+          </a:p>
+        </p:txBody>
+      </p:sp>
+      <p:sp>
+        <p:nvSpPr>
+          <p:cNvPr id="15" name="TextBox 14"/>
+          <p:cNvSpPr txBox="1"/>
+          <p:nvPr/>
+        </p:nvSpPr>
+        <p:spPr>
+          <a:xfrm>
+            <a:off x="7735824" y="3017520"/>
+            <a:ext cx="1554480" cy="228600"/>
+          </a:xfrm>
+          <a:prstGeom prst="rect">
+            <a:avLst/>
+          </a:prstGeom>
+          <a:noFill/>
+        </p:spPr>
+        <p:txBody>
+          <a:bodyPr wrap="none">
+            <a:spAutoFit/>
+          </a:bodyPr>
+          <a:lstStyle/>
+          <a:p>
+            <a:r>
+              <a:rPr sz="1000" b="1">
+                <a:solidFill>
+                  <a:srgbClr val="5B6B78"/>
+                </a:solidFill>
+              </a:rPr>
+              <a:t>MANUAL HOLD</a:t>
+            </a:r>
+          </a:p>
+        </p:txBody>
+      </p:sp>
+      <p:sp>
+        <p:nvSpPr>
+          <p:cNvPr id="16" name="TextBox 15"/>
+          <p:cNvSpPr txBox="1"/>
+          <p:nvPr/>
+        </p:nvSpPr>
+        <p:spPr>
+          <a:xfrm>
+            <a:off x="7735824" y="3310128"/>
+            <a:ext cx="1554480" cy="411480"/>
+          </a:xfrm>
+          <a:prstGeom prst="rect">
+            <a:avLst/>
+          </a:prstGeom>
+          <a:noFill/>
+        </p:spPr>
+        <p:txBody>
+          <a:bodyPr wrap="none">
+            <a:spAutoFit/>
+          </a:bodyPr>
+          <a:lstStyle/>
+          <a:p>
+            <a:pPr algn="ctr"/>
+            <a:r>
+              <a:rPr sz="2400" b="1">
+                <a:solidFill>
+                  <a:srgbClr val="C75C5C"/>
+                </a:solidFill>
+              </a:rPr>
+              <a:t>91</a:t>
+            </a:r>
+          </a:p>
+        </p:txBody>
+      </p:sp>
+      <p:sp>
+        <p:nvSpPr>
+          <p:cNvPr id="17" name="TextBox 16"/>
+          <p:cNvSpPr txBox="1"/>
+          <p:nvPr/>
+        </p:nvSpPr>
+        <p:spPr>
+          <a:xfrm>
+            <a:off x="7735824" y="3767328"/>
+            <a:ext cx="1554480" cy="320040"/>
+          </a:xfrm>
+          <a:prstGeom prst="rect">
+            <a:avLst/>
+          </a:prstGeom>
+          <a:noFill/>
+        </p:spPr>
+        <p:txBody>
+          <a:bodyPr wrap="none">
+            <a:spAutoFit/>
+          </a:bodyPr>
+          <a:lstStyle/>
+          <a:p>
+            <a:r>
+              <a:rPr sz="1000">
+                <a:solidFill>
+                  <a:srgbClr val="5B6B78"/>
+                </a:solidFill>
+              </a:rPr>
+              <a:t>Still requires review or approval.</a:t>
+            </a:r>
+          </a:p>
+        </p:txBody>
+      </p:sp>
+      <p:sp>
+        <p:nvSpPr>
+          <p:cNvPr id="18" name="Rounded Rectangle 17"/>
+          <p:cNvSpPr/>
+          <p:nvPr/>
+        </p:nvSpPr>
+        <p:spPr>
+          <a:xfrm>
+            <a:off x="9555480" y="2926080"/>
+            <a:ext cx="1828800" cy="1280160"/>
+          </a:xfrm>
+          <a:prstGeom prst="roundRect">
+            <a:avLst/>
+          </a:prstGeom>
+          <a:solidFill>
+            <a:srgbClr val="FFFFFF"/>
+          </a:solidFill>
+          <a:ln w="12700">
+            <a:solidFill>
+              <a:srgbClr val="D6DFE5"/>
+            </a:solidFill>
+          </a:ln>
+        </p:spPr>
+        <p:style>
+          <a:lnRef idx="1">
+            <a:schemeClr val="accent1"/>
+          </a:lnRef>
+          <a:fillRef idx="3">
+            <a:schemeClr val="accent1"/>
+          </a:fillRef>
+          <a:effectRef idx="2">
+            <a:schemeClr val="accent1"/>
+          </a:effectRef>
+          <a:fontRef idx="minor">
+            <a:schemeClr val="lt1"/>
+          </a:fontRef>
+        </p:style>
+        <p:txBody>
+          <a:bodyPr rtlCol="0" anchor="ctr"/>
+          <a:lstStyle/>
+          <a:p>
+            <a:pPr algn="ctr"/>
+          </a:p>
+        </p:txBody>
+      </p:sp>
+      <p:sp>
+        <p:nvSpPr>
+          <p:cNvPr id="19" name="TextBox 18"/>
+          <p:cNvSpPr txBox="1"/>
+          <p:nvPr/>
+        </p:nvSpPr>
+        <p:spPr>
+          <a:xfrm>
+            <a:off x="9701784" y="3017520"/>
+            <a:ext cx="1554480" cy="228600"/>
+          </a:xfrm>
+          <a:prstGeom prst="rect">
+            <a:avLst/>
+          </a:prstGeom>
+          <a:noFill/>
+        </p:spPr>
+        <p:txBody>
+          <a:bodyPr wrap="none">
+            <a:spAutoFit/>
+          </a:bodyPr>
+          <a:lstStyle/>
+          <a:p>
+            <a:r>
+              <a:rPr sz="1000" b="1">
+                <a:solidFill>
+                  <a:srgbClr val="5B6B78"/>
+                </a:solidFill>
+              </a:rPr>
+              <a:t>HOURS SAVED</a:t>
+            </a:r>
+          </a:p>
+        </p:txBody>
+      </p:sp>
+      <p:sp>
+        <p:nvSpPr>
+          <p:cNvPr id="20" name="TextBox 19"/>
+          <p:cNvSpPr txBox="1"/>
+          <p:nvPr/>
+        </p:nvSpPr>
+        <p:spPr>
+          <a:xfrm>
+            <a:off x="9701784" y="3310128"/>
+            <a:ext cx="1554480" cy="411480"/>
+          </a:xfrm>
+          <a:prstGeom prst="rect">
+            <a:avLst/>
+          </a:prstGeom>
+          <a:noFill/>
+        </p:spPr>
+        <p:txBody>
+          <a:bodyPr wrap="none">
+            <a:spAutoFit/>
+          </a:bodyPr>
+          <a:lstStyle/>
+          <a:p>
+            <a:pPr algn="ctr"/>
+            <a:r>
+              <a:rPr sz="2400" b="1">
+                <a:solidFill>
+                  <a:srgbClr val="2A9D8F"/>
+                </a:solidFill>
+              </a:rPr>
+              <a:t>41</a:t>
+            </a:r>
+          </a:p>
+        </p:txBody>
+      </p:sp>
+      <p:sp>
+        <p:nvSpPr>
+          <p:cNvPr id="21" name="TextBox 20"/>
+          <p:cNvSpPr txBox="1"/>
+          <p:nvPr/>
+        </p:nvSpPr>
+        <p:spPr>
+          <a:xfrm>
+            <a:off x="9701784" y="3767328"/>
+            <a:ext cx="1554480" cy="320040"/>
+          </a:xfrm>
+          <a:prstGeom prst="rect">
+            <a:avLst/>
+          </a:prstGeom>
+          <a:noFill/>
+        </p:spPr>
+        <p:txBody>
+          <a:bodyPr wrap="none">
+            <a:spAutoFit/>
+          </a:bodyPr>
+          <a:lstStyle/>
+          <a:p>
+            <a:r>
+              <a:rPr sz="1000">
+                <a:solidFill>
+                  <a:srgbClr val="5B6B78"/>
+                </a:solidFill>
+              </a:rPr>
+              <a:t>Recovered from the automation bundle.</a:t>
+            </a:r>
+          </a:p>
+        </p:txBody>
+      </p:sp>
+      <p:sp>
+        <p:nvSpPr>
+          <p:cNvPr id="22" name="TextBox 21"/>
+          <p:cNvSpPr txBox="1"/>
+          <p:nvPr/>
+        </p:nvSpPr>
+        <p:spPr>
+          <a:xfrm>
+            <a:off x="7360920" y="4572000"/>
+            <a:ext cx="4114800" cy="1188720"/>
+          </a:xfrm>
+          <a:prstGeom prst="rect">
+            <a:avLst/>
+          </a:prstGeom>
+          <a:noFill/>
+        </p:spPr>
+        <p:txBody>
+          <a:bodyPr wrap="none">
+            <a:spAutoFit/>
+          </a:bodyPr>
+          <a:lstStyle/>
           <a:p>
             <a:pPr>
               <a:spcAft>
@@ -8545,14 +9283,29 @@
               </a:defRPr>
             </a:pPr>
             <a:r>
-              <a:t>Unblock critical close checklist tasks - Critical checklist handoffs across reconciliation, journals, and reporting</a:t>
-            </a:r>
-          </a:p>
-        </p:txBody>
-      </p:sp>
-      <p:sp>
-        <p:nvSpPr>
-          <p:cNvPr id="8" name="TextBox 7"/>
+              <a:t>Run sheet logs timestamps, actions applied, hours saved, and posting state.</a:t>
+            </a:r>
+          </a:p>
+          <a:p>
+            <a:pPr>
+              <a:spcAft>
+                <a:spcPts val="800"/>
+              </a:spcAft>
+              <a:defRPr sz="1500">
+                <a:solidFill>
+                  <a:srgbClr val="0F1F2C"/>
+                </a:solidFill>
+              </a:defRPr>
+            </a:pPr>
+            <a:r>
+              <a:t>Before/after risk cards and agent tables make the automation effect transparent.</a:t>
+            </a:r>
+          </a:p>
+        </p:txBody>
+      </p:sp>
+      <p:sp>
+        <p:nvSpPr>
+          <p:cNvPr id="23" name="TextBox 22"/>
           <p:cNvSpPr txBox="1"/>
           <p:nvPr/>
         </p:nvSpPr>
@@ -8579,7 +9332,7 @@
                   <a:srgbClr val="5B6B78"/>
                 </a:solidFill>
               </a:rPr>
-              <a:t>NovaClose | Operating model</a:t>
+              <a:t>NovaClose | Automation controls</a:t>
             </a:r>
           </a:p>
         </p:txBody>
@@ -8593,6 +9346,364 @@
 </file>
 
 <file path=ppt/slides/slide8.xml><?xml version="1.0" encoding="utf-8"?>
+<p:sld xmlns:a="http://schemas.openxmlformats.org/drawingml/2006/main" xmlns:p="http://schemas.openxmlformats.org/presentationml/2006/main" xmlns:r="http://schemas.openxmlformats.org/officeDocument/2006/relationships">
+  <p:cSld>
+    <p:bg>
+      <p:bgPr>
+        <a:solidFill>
+          <a:srgbClr val="F5F9FC"/>
+        </a:solidFill>
+        <a:effectLst/>
+      </p:bgPr>
+    </p:bg>
+    <p:spTree>
+      <p:nvGrpSpPr>
+        <p:cNvPr id="1" name=""/>
+        <p:cNvGrpSpPr/>
+        <p:nvPr/>
+      </p:nvGrpSpPr>
+      <p:grpSpPr/>
+      <p:sp>
+        <p:nvSpPr>
+          <p:cNvPr id="2" name="TextBox 1"/>
+          <p:cNvSpPr txBox="1"/>
+          <p:nvPr/>
+        </p:nvSpPr>
+        <p:spPr>
+          <a:xfrm>
+            <a:off x="548640" y="411480"/>
+            <a:ext cx="7772400" cy="548640"/>
+          </a:xfrm>
+          <a:prstGeom prst="rect">
+            <a:avLst/>
+          </a:prstGeom>
+          <a:noFill/>
+        </p:spPr>
+        <p:txBody>
+          <a:bodyPr wrap="none">
+            <a:spAutoFit/>
+          </a:bodyPr>
+          <a:lstStyle/>
+          <a:p>
+            <a:r>
+              <a:rPr sz="2600" b="1">
+                <a:solidFill>
+                  <a:srgbClr val="0F1F2C"/>
+                </a:solidFill>
+              </a:rPr>
+              <a:t>How the CFO and operations team use it</a:t>
+            </a:r>
+          </a:p>
+        </p:txBody>
+      </p:sp>
+      <p:sp>
+        <p:nvSpPr>
+          <p:cNvPr id="3" name="TextBox 2"/>
+          <p:cNvSpPr txBox="1"/>
+          <p:nvPr/>
+        </p:nvSpPr>
+        <p:spPr>
+          <a:xfrm>
+            <a:off x="566928" y="914400"/>
+            <a:ext cx="9875520" cy="411480"/>
+          </a:xfrm>
+          <a:prstGeom prst="rect">
+            <a:avLst/>
+          </a:prstGeom>
+          <a:noFill/>
+        </p:spPr>
+        <p:txBody>
+          <a:bodyPr wrap="none">
+            <a:spAutoFit/>
+          </a:bodyPr>
+          <a:lstStyle/>
+          <a:p>
+            <a:r>
+              <a:rPr sz="1100">
+                <a:solidFill>
+                  <a:srgbClr val="5B6B78"/>
+                </a:solidFill>
+              </a:rPr>
+              <a:t>The app is designed to answer three questions fast: Where are we? What moved? What do we do next?</a:t>
+            </a:r>
+          </a:p>
+        </p:txBody>
+      </p:sp>
+      <p:sp>
+        <p:nvSpPr>
+          <p:cNvPr id="4" name="TextBox 3"/>
+          <p:cNvSpPr txBox="1"/>
+          <p:nvPr/>
+        </p:nvSpPr>
+        <p:spPr>
+          <a:xfrm>
+            <a:off x="731520" y="1417320"/>
+            <a:ext cx="5303520" cy="274320"/>
+          </a:xfrm>
+          <a:prstGeom prst="rect">
+            <a:avLst/>
+          </a:prstGeom>
+          <a:noFill/>
+        </p:spPr>
+        <p:txBody>
+          <a:bodyPr wrap="none">
+            <a:spAutoFit/>
+          </a:bodyPr>
+          <a:lstStyle/>
+          <a:p>
+            <a:r>
+              <a:rPr sz="1000" b="1">
+                <a:solidFill>
+                  <a:srgbClr val="5B6B78"/>
+                </a:solidFill>
+              </a:rPr>
+              <a:t>OPERATOR FLOW</a:t>
+            </a:r>
+          </a:p>
+        </p:txBody>
+      </p:sp>
+      <p:sp>
+        <p:nvSpPr>
+          <p:cNvPr id="5" name="TextBox 4"/>
+          <p:cNvSpPr txBox="1"/>
+          <p:nvPr/>
+        </p:nvSpPr>
+        <p:spPr>
+          <a:xfrm>
+            <a:off x="731520" y="1691640"/>
+            <a:ext cx="5303520" cy="4023360"/>
+          </a:xfrm>
+          <a:prstGeom prst="rect">
+            <a:avLst/>
+          </a:prstGeom>
+          <a:noFill/>
+        </p:spPr>
+        <p:txBody>
+          <a:bodyPr wrap="none">
+            <a:spAutoFit/>
+          </a:bodyPr>
+          <a:lstStyle/>
+          <a:p>
+            <a:pPr>
+              <a:spcAft>
+                <a:spcPts val="800"/>
+              </a:spcAft>
+              <a:defRPr sz="1500">
+                <a:solidFill>
+                  <a:srgbClr val="0F1F2C"/>
+                </a:solidFill>
+              </a:defRPr>
+            </a:pPr>
+            <a:r>
+              <a:t>1. Load the workbook and validate the period.</a:t>
+            </a:r>
+          </a:p>
+          <a:p>
+            <a:pPr>
+              <a:spcAft>
+                <a:spcPts val="800"/>
+              </a:spcAft>
+              <a:defRPr sz="1500">
+                <a:solidFill>
+                  <a:srgbClr val="0F1F2C"/>
+                </a:solidFill>
+              </a:defRPr>
+            </a:pPr>
+            <a:r>
+              <a:t>2. Review the Command Centre before/after readiness signal.</a:t>
+            </a:r>
+          </a:p>
+          <a:p>
+            <a:pPr>
+              <a:spcAft>
+                <a:spcPts val="800"/>
+              </a:spcAft>
+              <a:defRPr sz="1500">
+                <a:solidFill>
+                  <a:srgbClr val="0F1F2C"/>
+                </a:solidFill>
+              </a:defRPr>
+            </a:pPr>
+            <a:r>
+              <a:t>3. Run the automation bundle from Month-End Steps.</a:t>
+            </a:r>
+          </a:p>
+          <a:p>
+            <a:pPr>
+              <a:spcAft>
+                <a:spcPts val="800"/>
+              </a:spcAft>
+              <a:defRPr sz="1500">
+                <a:solidFill>
+                  <a:srgbClr val="0F1F2C"/>
+                </a:solidFill>
+              </a:defRPr>
+            </a:pPr>
+            <a:r>
+              <a:t>4. Work the top three priorities and owner queue.</a:t>
+            </a:r>
+          </a:p>
+          <a:p>
+            <a:pPr>
+              <a:spcAft>
+                <a:spcPts val="800"/>
+              </a:spcAft>
+              <a:defRPr sz="1500">
+                <a:solidFill>
+                  <a:srgbClr val="0F1F2C"/>
+                </a:solidFill>
+              </a:defRPr>
+            </a:pPr>
+            <a:r>
+              <a:t>5. Use AI Copilot for blocker, entity, and variance questions.</a:t>
+            </a:r>
+          </a:p>
+        </p:txBody>
+      </p:sp>
+      <p:sp>
+        <p:nvSpPr>
+          <p:cNvPr id="6" name="TextBox 5"/>
+          <p:cNvSpPr txBox="1"/>
+          <p:nvPr/>
+        </p:nvSpPr>
+        <p:spPr>
+          <a:xfrm>
+            <a:off x="6217920" y="1417320"/>
+            <a:ext cx="5212080" cy="274320"/>
+          </a:xfrm>
+          <a:prstGeom prst="rect">
+            <a:avLst/>
+          </a:prstGeom>
+          <a:noFill/>
+        </p:spPr>
+        <p:txBody>
+          <a:bodyPr wrap="none">
+            <a:spAutoFit/>
+          </a:bodyPr>
+          <a:lstStyle/>
+          <a:p>
+            <a:r>
+              <a:rPr sz="1000" b="1">
+                <a:solidFill>
+                  <a:srgbClr val="5B6B78"/>
+                </a:solidFill>
+              </a:rPr>
+              <a:t>TOP FOCUS AREAS FROM THE CURRENT DATA</a:t>
+            </a:r>
+          </a:p>
+        </p:txBody>
+      </p:sp>
+      <p:sp>
+        <p:nvSpPr>
+          <p:cNvPr id="7" name="TextBox 6"/>
+          <p:cNvSpPr txBox="1"/>
+          <p:nvPr/>
+        </p:nvSpPr>
+        <p:spPr>
+          <a:xfrm>
+            <a:off x="6217920" y="1691640"/>
+            <a:ext cx="5212080" cy="4023360"/>
+          </a:xfrm>
+          <a:prstGeom prst="rect">
+            <a:avLst/>
+          </a:prstGeom>
+          <a:noFill/>
+        </p:spPr>
+        <p:txBody>
+          <a:bodyPr wrap="none">
+            <a:spAutoFit/>
+          </a:bodyPr>
+          <a:lstStyle/>
+          <a:p>
+            <a:pPr>
+              <a:spcAft>
+                <a:spcPts val="800"/>
+              </a:spcAft>
+              <a:defRPr sz="1500">
+                <a:solidFill>
+                  <a:srgbClr val="0F1F2C"/>
+                </a:solidFill>
+              </a:defRPr>
+            </a:pPr>
+            <a:r>
+              <a:t>Clear pending GL reviews and approvals - Final account review and downstream controller sign-off</a:t>
+            </a:r>
+          </a:p>
+          <a:p>
+            <a:pPr>
+              <a:spcAft>
+                <a:spcPts val="800"/>
+              </a:spcAft>
+              <a:defRPr sz="1500">
+                <a:solidFill>
+                  <a:srgbClr val="0F1F2C"/>
+                </a:solidFill>
+              </a:defRPr>
+            </a:pPr>
+            <a:r>
+              <a:t>Resolve bank reconciliation exceptions - Cash certification and treasury close readiness</a:t>
+            </a:r>
+          </a:p>
+          <a:p>
+            <a:pPr>
+              <a:spcAft>
+                <a:spcPts val="800"/>
+              </a:spcAft>
+              <a:defRPr sz="1500">
+                <a:solidFill>
+                  <a:srgbClr val="0F1F2C"/>
+                </a:solidFill>
+              </a:defRPr>
+            </a:pPr>
+            <a:r>
+              <a:t>Unblock critical close checklist tasks - Critical checklist handoffs across reconciliation, journals, and reporting</a:t>
+            </a:r>
+          </a:p>
+        </p:txBody>
+      </p:sp>
+      <p:sp>
+        <p:nvSpPr>
+          <p:cNvPr id="8" name="TextBox 7"/>
+          <p:cNvSpPr txBox="1"/>
+          <p:nvPr/>
+        </p:nvSpPr>
+        <p:spPr>
+          <a:xfrm>
+            <a:off x="548640" y="6400800"/>
+            <a:ext cx="10607040" cy="274320"/>
+          </a:xfrm>
+          <a:prstGeom prst="rect">
+            <a:avLst/>
+          </a:prstGeom>
+          <a:noFill/>
+        </p:spPr>
+        <p:txBody>
+          <a:bodyPr wrap="none">
+            <a:spAutoFit/>
+          </a:bodyPr>
+          <a:lstStyle/>
+          <a:p>
+            <a:pPr algn="r"/>
+            <a:r>
+              <a:rPr sz="900">
+                <a:solidFill>
+                  <a:srgbClr val="5B6B78"/>
+                </a:solidFill>
+              </a:rPr>
+              <a:t>NovaClose | Operating model</a:t>
+            </a:r>
+          </a:p>
+        </p:txBody>
+      </p:sp>
+    </p:spTree>
+  </p:cSld>
+  <p:clrMapOvr>
+    <a:masterClrMapping/>
+  </p:clrMapOvr>
+</p:sld>
+</file>
+
+<file path=ppt/slides/slide9.xml><?xml version="1.0" encoding="utf-8"?>
 <p:sld xmlns:a="http://schemas.openxmlformats.org/drawingml/2006/main" xmlns:p="http://schemas.openxmlformats.org/presentationml/2006/main" xmlns:r="http://schemas.openxmlformats.org/officeDocument/2006/relationships">
   <p:cSld>
     <p:bg>

</xml_diff>